<commit_message>
Thicken Weeks 6-9, 11-12; sync docs to new exam structure
Adds worked, concrete material to the light build weeks: candidate
micro-tools per discipline and a fix-it procedure (W6); the three
instructions shown working against a good and a bad answer, plus document
preparation (W7); a written-out test set with the
population/time/jurisdiction pattern for unanswerable questions, and what
to do with each finding (W8); a written-out three-step chain and the
new-colleague test (W9); golden-example composition and pack maintenance
(W11); what a poisoned document actually looks like and incident response
(W12).

All 14 decks now estimate 44-62 minutes including activity and questions.
308 slides, 45,855 words of verbatim script.

Co-Authored-By: Claude Opus 5 <noreply@anthropic.com>
</commit_message>
<xml_diff>
--- a/Lectures/week07/week07.pptx
+++ b/Lectures/week07/week07.pptx
@@ -24,6 +24,8 @@
     <p:sldId id="272" r:id="rId24"/>
     <p:sldId id="273" r:id="rId25"/>
     <p:sldId id="274" r:id="rId26"/>
+    <p:sldId id="275" r:id="rId27"/>
+    <p:sldId id="276" r:id="rId28"/>
   </p:sldIdLst>
   <p:sldSz cx="12191695" cy="6858000" type="screen4x3"/>
   <p:notesSz cx="6858000" cy="9144000"/>
@@ -1027,81 +1029,88 @@
           <a:lstStyle/>
           <a:p>
             <a:r>
-              <a:t>Three failure modes. These map exactly onto the open-book exam analogy from earlier, and I'll</a:t>
-            </a:r>
-          </a:p>
-          <a:p>
-            <a:r>
-              <a:t>examine you on them.</a:t>
+              <a:t>Let me show you the difference concretely, because it's easy to nod at the three instructions and</a:t>
+            </a:r>
+          </a:p>
+          <a:p>
+            <a:r>
+              <a:t>still accept a bad answer.</a:t>
             </a:r>
           </a:p>
           <a:p/>
           <a:p>
             <a:r>
-              <a:t>Answered from memory. Your documents didn't contain it; the model knew something adjacent and</a:t>
-            </a:r>
-          </a:p>
-          <a:p>
-            <a:r>
-              <a:t>used that. How you detect it: the answer has no quotation, or has a vague gesture instead of a</a:t>
-            </a:r>
-          </a:p>
-          <a:p>
-            <a:r>
-              <a:t>sentence. If there's no quote, assume memory.</a:t>
+              <a:t>The question: what's the maximum period for submitting an appeal?</a:t>
             </a:r>
           </a:p>
           <a:p/>
           <a:p>
             <a:r>
-              <a:t>Retrieved the wrong passage. The right words appeared somewhere unrelated — the word "notice"</a:t>
-            </a:r>
-          </a:p>
-          <a:p>
-            <a:r>
-              <a:t>appears in a clause about notices to third parties, not about termination. The quotation is</a:t>
-            </a:r>
-          </a:p>
-          <a:p>
-            <a:r>
-              <a:t>completely genuine. The conclusion is wrong. How you detect it: read the quoted passage in its</a:t>
-            </a:r>
-          </a:p>
-          <a:p>
-            <a:r>
-              <a:t>original context, not in isolation.</a:t>
+              <a:t>A good answer. Fifteen working days from notification. Then the source: a quoted sentence, with a</a:t>
+            </a:r>
+          </a:p>
+          <a:p>
+            <a:r>
+              <a:t>regulation number. You can search your document for that sentence and find clause 8.2 in about</a:t>
+            </a:r>
+          </a:p>
+          <a:p>
+            <a:r>
+              <a:t>five seconds. And notice the quotation contains the number, so the answer and its evidence agree</a:t>
+            </a:r>
+          </a:p>
+          <a:p>
+            <a:r>
+              <a:t>in a way you can see.</a:t>
             </a:r>
           </a:p>
           <a:p/>
           <a:p>
             <a:r>
-              <a:t>And over-read the passage — the subtlest one and my personal favourite for exam questions. The</a:t>
-            </a:r>
-          </a:p>
-          <a:p>
-            <a:r>
-              <a:t>source says something narrower than the answer claims. "May" becomes "must." "In some cases"</a:t>
-            </a:r>
-          </a:p>
-          <a:p>
-            <a:r>
-              <a:t>becomes "in all cases." An example becomes a rule. How you detect it: compare the strength of</a:t>
-            </a:r>
-          </a:p>
-          <a:p>
-            <a:r>
-              <a:t>the claim against the strength of the quote. If the answer is more confident than the sentence</a:t>
-            </a:r>
-          </a:p>
-          <a:p>
-            <a:r>
-              <a:t>it cites, something has been added.</a:t>
+              <a:t>Now the bad answer. "Appeals are generally expected to be submitted promptly, typically within</a:t>
+            </a:r>
+          </a:p>
+          <a:p>
+            <a:r>
+              <a:t>two to four weeks of the decision."</a:t>
             </a:r>
           </a:p>
           <a:p/>
           <a:p>
             <a:r>
-              <a:t>Learn these three by name.</a:t>
+              <a:t>Read it again and notice the tells. "Generally expected." "Typically." A range instead of a</a:t>
+            </a:r>
+          </a:p>
+          <a:p>
+            <a:r>
+              <a:t>figure. No quotation. No clause number.</a:t>
+            </a:r>
+          </a:p>
+          <a:p/>
+          <a:p>
+            <a:r>
+              <a:t>That is what answering from memory looks like — and it's plausible, professional-sounding, and</a:t>
+            </a:r>
+          </a:p>
+          <a:p>
+            <a:r>
+              <a:t>completely useless. If you skim it while thinking about something else, you take away "two to four</a:t>
+            </a:r>
+          </a:p>
+          <a:p>
+            <a:r>
+              <a:t>weeks" and act on it.</a:t>
+            </a:r>
+          </a:p>
+          <a:p/>
+          <a:p>
+            <a:r>
+              <a:t>The hedging is the signal. A grounded answer working from an actual passage tends to be more</a:t>
+            </a:r>
+          </a:p>
+          <a:p>
+            <a:r>
+              <a:t>specific than a remembered one, not less. When the answer goes vague, ask where the quote is.</a:t>
             </a:r>
           </a:p>
         </p:txBody>
@@ -1171,7 +1180,99 @@
           <a:lstStyle/>
           <a:p>
             <a:r>
-              <a:t>Part four. Twenty minutes. Everything you need is provided if you didn't bring documents.</a:t>
+              <a:t>This slide is the practical one, and it's the thing people skip because it feels like admin</a:t>
+            </a:r>
+          </a:p>
+          <a:p>
+            <a:r>
+              <a:t>rather than work.</a:t>
+            </a:r>
+          </a:p>
+          <a:p/>
+          <a:p>
+            <a:r>
+              <a:t>Fifteen minutes of document preparation buys more than any amount of prompt rewriting. Genuinely.</a:t>
+            </a:r>
+          </a:p>
+          <a:p>
+            <a:r>
+              <a:t>If a grounded assistant is disappointing you, the source is more often the problem than the</a:t>
+            </a:r>
+          </a:p>
+          <a:p>
+            <a:r>
+              <a:t>prompt.</a:t>
+            </a:r>
+          </a:p>
+          <a:p/>
+          <a:p>
+            <a:r>
+              <a:t>Four moves.</a:t>
+            </a:r>
+          </a:p>
+          <a:p/>
+          <a:p>
+            <a:r>
+              <a:t>Split a long document into sections of roughly one topic each, with descriptive headings. This</a:t>
+            </a:r>
+          </a:p>
+          <a:p>
+            <a:r>
+              <a:t>matters because retrieval pulls passages — if your passages each cover one thing, the right one</a:t>
+            </a:r>
+          </a:p>
+          <a:p>
+            <a:r>
+              <a:t>gets found.</a:t>
+            </a:r>
+          </a:p>
+          <a:p/>
+          <a:p>
+            <a:r>
+              <a:t>Replace "as described above" and "see section 3" with the actual content where you can. Remember</a:t>
+            </a:r>
+          </a:p>
+          <a:p>
+            <a:r>
+              <a:t>why: a retrieved passage arrives on its own, and a cross-reference to something that wasn't</a:t>
+            </a:r>
+          </a:p>
+          <a:p>
+            <a:r>
+              <a:t>retrieved is a sentence that means nothing — which the model will interpret anyway.</a:t>
+            </a:r>
+          </a:p>
+          <a:p/>
+          <a:p>
+            <a:r>
+              <a:t>Convert scanned pages to real text. If the text is a picture, nothing is retrievable at all, and</a:t>
+            </a:r>
+          </a:p>
+          <a:p>
+            <a:r>
+              <a:t>this is very common with older institutional documents.</a:t>
+            </a:r>
+          </a:p>
+          <a:p/>
+          <a:p>
+            <a:r>
+              <a:t>And delete material irrelevant to the questions you'll ask. It competes for retrieval and crowds</a:t>
+            </a:r>
+          </a:p>
+          <a:p>
+            <a:r>
+              <a:t>out what you wanted.</a:t>
+            </a:r>
+          </a:p>
+          <a:p/>
+          <a:p>
+            <a:r>
+              <a:t>Then re-run the same questions and compare. That comparison is the fastest improvement available</a:t>
+            </a:r>
+          </a:p>
+          <a:p>
+            <a:r>
+              <a:t>to you in this entire course.</a:t>
             </a:r>
           </a:p>
         </p:txBody>
@@ -1241,82 +1342,81 @@
           <a:lstStyle/>
           <a:p>
             <a:r>
-              <a:t>Twenty minutes. Four steps.</a:t>
+              <a:t>Three failure modes. These map exactly onto the open-book exam analogy from earlier, and I'll</a:t>
+            </a:r>
+          </a:p>
+          <a:p>
+            <a:r>
+              <a:t>examine you on them.</a:t>
             </a:r>
           </a:p>
           <a:p/>
           <a:p>
             <a:r>
-              <a:t>One. Choose your sources — three to five short documents. Bring your own if you have them.</a:t>
-            </a:r>
-          </a:p>
-          <a:p>
-            <a:r>
-              <a:t>Otherwise take a pack from me: I have a clinical guideline extract, a statute extract, a set of</a:t>
-            </a:r>
-          </a:p>
-          <a:p>
-            <a:r>
-              <a:t>course regulations, an annual report, and a technical standard. Pick whichever is closest to</a:t>
-            </a:r>
-          </a:p>
-          <a:p>
-            <a:r>
-              <a:t>your field. All public material, so no data concerns.</a:t>
+              <a:t>Answered from memory. Your documents didn't contain it; the model knew something adjacent and</a:t>
+            </a:r>
+          </a:p>
+          <a:p>
+            <a:r>
+              <a:t>used that. How you detect it: the answer has no quotation, or has a vague gesture instead of a</a:t>
+            </a:r>
+          </a:p>
+          <a:p>
+            <a:r>
+              <a:t>sentence. If there's no quote, assume memory.</a:t>
             </a:r>
           </a:p>
           <a:p/>
           <a:p>
             <a:r>
-              <a:t>Two. Load them into any tool that lets you attach documents and ask questions about them.</a:t>
-            </a:r>
-          </a:p>
-          <a:p>
-            <a:r>
-              <a:t>Several free assistants do this directly. Notebook-style tools do it particularly well. Any of</a:t>
-            </a:r>
-          </a:p>
-          <a:p>
-            <a:r>
-              <a:t>them works — we're doing a general technique, not a product tutorial.</a:t>
+              <a:t>Retrieved the wrong passage. The right words appeared somewhere unrelated — the word "notice"</a:t>
+            </a:r>
+          </a:p>
+          <a:p>
+            <a:r>
+              <a:t>appears in a clause about notices to third parties, not about termination. The quotation is</a:t>
+            </a:r>
+          </a:p>
+          <a:p>
+            <a:r>
+              <a:t>completely genuine. The conclusion is wrong. How you detect it: read the quoted passage in its</a:t>
+            </a:r>
+          </a:p>
+          <a:p>
+            <a:r>
+              <a:t>original context, not in isolation.</a:t>
             </a:r>
           </a:p>
           <a:p/>
           <a:p>
             <a:r>
-              <a:t>Three. Add the three instructions from earlier. Answer only from the documents. Quote the</a:t>
-            </a:r>
-          </a:p>
-          <a:p>
-            <a:r>
-              <a:t>supporting sentence. Reply NOT IN SOURCES if it isn't there.</a:t>
+              <a:t>And over-read the passage — the subtlest one and my personal favourite for exam questions. The</a:t>
+            </a:r>
+          </a:p>
+          <a:p>
+            <a:r>
+              <a:t>source says something narrower than the answer claims. "May" becomes "must." "In some cases"</a:t>
+            </a:r>
+          </a:p>
+          <a:p>
+            <a:r>
+              <a:t>becomes "in all cases." An example becomes a rule. How you detect it: compare the strength of</a:t>
+            </a:r>
+          </a:p>
+          <a:p>
+            <a:r>
+              <a:t>the claim against the strength of the quote. If the answer is more confident than the sentence</a:t>
+            </a:r>
+          </a:p>
+          <a:p>
+            <a:r>
+              <a:t>it cites, something has been added.</a:t>
             </a:r>
           </a:p>
           <a:p/>
           <a:p>
             <a:r>
-              <a:t>Four, and this is the actual exercise: ask five questions, and check every single quotation</a:t>
-            </a:r>
-          </a:p>
-          <a:p>
-            <a:r>
-              <a:t>against the source. Not four of them. All five.</a:t>
-            </a:r>
-          </a:p>
-          <a:p/>
-          <a:p>
-            <a:r>
-              <a:t>[Circulate. The most common thing to catch: people accept a quotation without checking it.</a:t>
-            </a:r>
-          </a:p>
-          <a:p>
-            <a:r>
-              <a:t>Ask "did you find that sentence?" and watch what happens. If nobody is building, work through</a:t>
-            </a:r>
-          </a:p>
-          <a:p>
-            <a:r>
-              <a:t>three questions on the provided pack on screen.]</a:t>
+              <a:t>Learn these three by name.</a:t>
             </a:r>
           </a:p>
         </p:txBody>
@@ -1386,83 +1486,7 @@
           <a:lstStyle/>
           <a:p>
             <a:r>
-              <a:t>What typically happens.</a:t>
-            </a:r>
-          </a:p>
-          <a:p/>
-          <a:p>
-            <a:r>
-              <a:t>With the three instructions in place, it refused at least once — and when you checked, the</a:t>
-            </a:r>
-          </a:p>
-          <a:p>
-            <a:r>
-              <a:t>refusal was correct. That's the system working. Notice how much better that feels than a</a:t>
-            </a:r>
-          </a:p>
-          <a:p>
-            <a:r>
-              <a:t>confident answer you have to disprove.</a:t>
-            </a:r>
-          </a:p>
-          <a:p/>
-          <a:p>
-            <a:r>
-              <a:t>Quotations were usually genuine. "Usually" is the operative word and it's why you check.</a:t>
-            </a:r>
-          </a:p>
-          <a:p/>
-          <a:p>
-            <a:r>
-              <a:t>At least one answer was broader than the sentence it quoted. That's over-reading, and it's the</a:t>
-            </a:r>
-          </a:p>
-          <a:p>
-            <a:r>
-              <a:t>most common of the three failures. If you didn't spot one, look again — go back and compare</a:t>
-            </a:r>
-          </a:p>
-          <a:p>
-            <a:r>
-              <a:t>each claim with its quote for strength rather than content.</a:t>
-            </a:r>
-          </a:p>
-          <a:p/>
-          <a:p>
-            <a:r>
-              <a:t>And questions spanning several documents were answered worse than questions inside a single</a:t>
-            </a:r>
-          </a:p>
-          <a:p>
-            <a:r>
-              <a:t>document.</a:t>
-            </a:r>
-          </a:p>
-          <a:p/>
-          <a:p>
-            <a:r>
-              <a:t>That last one is structural, and it's the bold line. Retrieval pulls passages, not whole</a:t>
-            </a:r>
-          </a:p>
-          <a:p>
-            <a:r>
-              <a:t>documents. So a question whose answer requires combining three separate places is fragile —</a:t>
-            </a:r>
-          </a:p>
-          <a:p>
-            <a:r>
-              <a:t>each piece has to be retrieved, and if one isn't, the model fills the gap.</a:t>
-            </a:r>
-          </a:p>
-          <a:p/>
-          <a:p>
-            <a:r>
-              <a:t>Practical consequence: ask narrow questions of grounded systems. If you need a synthesis across</a:t>
-            </a:r>
-          </a:p>
-          <a:p>
-            <a:r>
-              <a:t>sources, do it in steps and check each step. That's a design decision you now know to make.</a:t>
+              <a:t>Part four. Twenty minutes. Everything you need is provided if you didn't bring documents.</a:t>
             </a:r>
           </a:p>
         </p:txBody>
@@ -1532,72 +1556,82 @@
           <a:lstStyle/>
           <a:p>
             <a:r>
-              <a:t>What's examinable from today. Five items, and this week is heavily represented on both exams.</a:t>
+              <a:t>Twenty minutes. Four steps.</a:t>
             </a:r>
           </a:p>
           <a:p/>
           <a:p>
             <a:r>
-              <a:t>Grounding: placing relevant passages from chosen sources into the context so the model answers</a:t>
-            </a:r>
-          </a:p>
-          <a:p>
-            <a:r>
-              <a:t>from them rather than memory. Know that RAG means this and nothing more mysterious.</a:t>
+              <a:t>One. Choose your sources — three to five short documents. Bring your own if you have them.</a:t>
+            </a:r>
+          </a:p>
+          <a:p>
+            <a:r>
+              <a:t>Otherwise take a pack from me: I have a clinical guideline extract, a statute extract, a set of</a:t>
+            </a:r>
+          </a:p>
+          <a:p>
+            <a:r>
+              <a:t>course regulations, an annual report, and a technical standard. Pick whichever is closest to</a:t>
+            </a:r>
+          </a:p>
+          <a:p>
+            <a:r>
+              <a:t>your field. All public material, so no data concerns.</a:t>
             </a:r>
           </a:p>
           <a:p/>
           <a:p>
             <a:r>
-              <a:t>What it does and doesn't do. Changes where the answer comes from. Does not install a truth</a:t>
-            </a:r>
-          </a:p>
-          <a:p>
-            <a:r>
-              <a:t>check. Does not fix a wrong source — and I may well give you a scenario where the source itself</a:t>
-            </a:r>
-          </a:p>
-          <a:p>
-            <a:r>
-              <a:t>is out of date and ask what grounding did and didn't help with.</a:t>
+              <a:t>Two. Load them into any tool that lets you attach documents and ask questions about them.</a:t>
+            </a:r>
+          </a:p>
+          <a:p>
+            <a:r>
+              <a:t>Several free assistants do this directly. Notebook-style tools do it particularly well. Any of</a:t>
+            </a:r>
+          </a:p>
+          <a:p>
+            <a:r>
+              <a:t>them works — we're doing a general technique, not a product tutorial.</a:t>
             </a:r>
           </a:p>
           <a:p/>
           <a:p>
             <a:r>
-              <a:t>Why prompting cannot substitute. Instructions change tone and shape, never available</a:t>
-            </a:r>
-          </a:p>
-          <a:p>
-            <a:r>
-              <a:t>information. Expect a question that offers "be accurate" as a tempting wrong answer.</a:t>
+              <a:t>Three. Add the three instructions from earlier. Answer only from the documents. Quote the</a:t>
+            </a:r>
+          </a:p>
+          <a:p>
+            <a:r>
+              <a:t>supporting sentence. Reply NOT IN SOURCES if it isn't there.</a:t>
             </a:r>
           </a:p>
           <a:p/>
           <a:p>
             <a:r>
-              <a:t>The three verification instructions, and specifically why the refusal string should be fixed</a:t>
-            </a:r>
-          </a:p>
-          <a:p>
-            <a:r>
-              <a:t>and visible.</a:t>
+              <a:t>Four, and this is the actual exercise: ask five questions, and check every single quotation</a:t>
+            </a:r>
+          </a:p>
+          <a:p>
+            <a:r>
+              <a:t>against the source. Not four of them. All five.</a:t>
             </a:r>
           </a:p>
           <a:p/>
           <a:p>
             <a:r>
-              <a:t>And the three grounded failure modes by name: answered from memory, retrieved the wrong</a:t>
-            </a:r>
-          </a:p>
-          <a:p>
-            <a:r>
-              <a:t>passage, over-read the passage. I'll give you an answer and a source and ask which one it is.</a:t>
-            </a:r>
-          </a:p>
-          <a:p>
-            <a:r>
-              <a:t>That's a guaranteed exam question, so practise it.</a:t>
+              <a:t>[Circulate. The most common thing to catch: people accept a quotation without checking it.</a:t>
+            </a:r>
+          </a:p>
+          <a:p>
+            <a:r>
+              <a:t>Ask "did you find that sentence?" and watch what happens. If nobody is building, work through</a:t>
+            </a:r>
+          </a:p>
+          <a:p>
+            <a:r>
+              <a:t>three questions on the provided pack on screen.]</a:t>
             </a:r>
           </a:p>
         </p:txBody>
@@ -1667,85 +1701,83 @@
           <a:lstStyle/>
           <a:p>
             <a:r>
-              <a:t>Five things.</a:t>
+              <a:t>What typically happens.</a:t>
             </a:r>
           </a:p>
           <a:p/>
           <a:p>
             <a:r>
-              <a:t>You cannot prompt your way to information the model doesn't have. You have to supply it.</a:t>
+              <a:t>With the three instructions in place, it refused at least once — and when you checked, the</a:t>
+            </a:r>
+          </a:p>
+          <a:p>
+            <a:r>
+              <a:t>refusal was correct. That's the system working. Notice how much better that feels than a</a:t>
+            </a:r>
+          </a:p>
+          <a:p>
+            <a:r>
+              <a:t>confident answer you have to disprove.</a:t>
             </a:r>
           </a:p>
           <a:p/>
           <a:p>
             <a:r>
-              <a:t>Grounding puts your passages into the context at the moment of answering. That's all RAG</a:t>
-            </a:r>
-          </a:p>
-          <a:p>
-            <a:r>
-              <a:t>means, and you should now be immune to people using the acronym to sound impressive.</a:t>
+              <a:t>Quotations were usually genuine. "Usually" is the operative word and it's why you check.</a:t>
             </a:r>
           </a:p>
           <a:p/>
           <a:p>
             <a:r>
-              <a:t>It changes where the answer comes from. It does not install a truth check. Please hold both</a:t>
-            </a:r>
-          </a:p>
-          <a:p>
-            <a:r>
-              <a:t>halves of that sentence.</a:t>
+              <a:t>At least one answer was broader than the sentence it quoted. That's over-reading, and it's the</a:t>
+            </a:r>
+          </a:p>
+          <a:p>
+            <a:r>
+              <a:t>most common of the three failures. If you didn't spot one, look again — go back and compare</a:t>
+            </a:r>
+          </a:p>
+          <a:p>
+            <a:r>
+              <a:t>each claim with its quote for strength rather than content.</a:t>
             </a:r>
           </a:p>
           <a:p/>
           <a:p>
             <a:r>
-              <a:t>Ask for quotations, and then actually check them — because the quotation marks feel like</a:t>
-            </a:r>
-          </a:p>
-          <a:p>
-            <a:r>
-              <a:t>verification and are not verification.</a:t>
+              <a:t>And questions spanning several documents were answered worse than questions inside a single</a:t>
+            </a:r>
+          </a:p>
+          <a:p>
+            <a:r>
+              <a:t>document.</a:t>
             </a:r>
           </a:p>
           <a:p/>
           <a:p>
             <a:r>
-              <a:t>And the three failures: answered from memory, wrong passage, over-read.</a:t>
+              <a:t>That last one is structural, and it's the bold line. Retrieval pulls passages, not whole</a:t>
+            </a:r>
+          </a:p>
+          <a:p>
+            <a:r>
+              <a:t>documents. So a question whose answer requires combining three separate places is fragile —</a:t>
+            </a:r>
+          </a:p>
+          <a:p>
+            <a:r>
+              <a:t>each piece has to be retrieved, and if one isn't, the model fills the gap.</a:t>
             </a:r>
           </a:p>
           <a:p/>
           <a:p>
             <a:r>
-              <a:t>Next week we do the thing that makes all of this real. You'll build ten questions designed to</a:t>
-            </a:r>
-          </a:p>
-          <a:p>
-            <a:r>
-              <a:t>break what you made today — seven it should answer, and three it cannot possibly answer from</a:t>
-            </a:r>
-          </a:p>
-          <a:p>
-            <a:r>
-              <a:t>your sources. And you'll watch a system you built an hour ago answer those three anyway,</a:t>
-            </a:r>
-          </a:p>
-          <a:p>
-            <a:r>
-              <a:t>confidently.</a:t>
-            </a:r>
-          </a:p>
-          <a:p/>
-          <a:p>
-            <a:r>
-              <a:t>I'd rather you saw that here than discovered it at work.</a:t>
-            </a:r>
-          </a:p>
-          <a:p/>
-          <a:p>
-            <a:r>
-              <a:t>Questions?</a:t>
+              <a:t>Practical consequence: ask narrow questions of grounded systems. If you need a synthesis across</a:t>
+            </a:r>
+          </a:p>
+          <a:p>
+            <a:r>
+              <a:t>sources, do it in steps and check each step. That's a design decision you now know to make.</a:t>
             </a:r>
           </a:p>
         </p:txBody>
@@ -1815,72 +1847,72 @@
           <a:lstStyle/>
           <a:p>
             <a:r>
-              <a:t>Take questions here.</a:t>
+              <a:t>What's examinable from today. Five items, and this week is heavily represented on both exams.</a:t>
             </a:r>
           </a:p>
           <a:p/>
           <a:p>
             <a:r>
-              <a:t>Common ones:</a:t>
+              <a:t>Grounding: placing relevant passages from chosen sources into the context so the model answers</a:t>
+            </a:r>
+          </a:p>
+          <a:p>
+            <a:r>
+              <a:t>from them rather than memory. Know that RAG means this and nothing more mysterious.</a:t>
             </a:r>
           </a:p>
           <a:p/>
           <a:p>
             <a:r>
-              <a:t>"Which tool is best for this?" — Several work well and they change. What matters is that it</a:t>
-            </a:r>
-          </a:p>
-          <a:p>
-            <a:r>
-              <a:t>accepts your documents and lets you ask questions about them. Try two; use whichever handles</a:t>
-            </a:r>
-          </a:p>
-          <a:p>
-            <a:r>
-              <a:t>your file types.</a:t>
+              <a:t>What it does and doesn't do. Changes where the answer comes from. Does not install a truth</a:t>
+            </a:r>
+          </a:p>
+          <a:p>
+            <a:r>
+              <a:t>check. Does not fix a wrong source — and I may well give you a scenario where the source itself</a:t>
+            </a:r>
+          </a:p>
+          <a:p>
+            <a:r>
+              <a:t>is out of date and ask what grounding did and didn't help with.</a:t>
             </a:r>
           </a:p>
           <a:p/>
           <a:p>
             <a:r>
-              <a:t>"Can I ground it on a website instead of files?" — Often yes. Same principles apply, plus you</a:t>
-            </a:r>
-          </a:p>
-          <a:p>
-            <a:r>
-              <a:t>inherit whatever is wrong on the website, and it may change under you without notice.</a:t>
+              <a:t>Why prompting cannot substitute. Instructions change tone and shape, never available</a:t>
+            </a:r>
+          </a:p>
+          <a:p>
+            <a:r>
+              <a:t>information. Expect a question that offers "be accurate" as a tempting wrong answer.</a:t>
             </a:r>
           </a:p>
           <a:p/>
           <a:p>
             <a:r>
-              <a:t>"Is my document used to train the model?" — Depends entirely on the service and the settings,</a:t>
-            </a:r>
-          </a:p>
-          <a:p>
-            <a:r>
-              <a:t>and it is genuinely worth reading the terms for anything institutional. That's week twelve, and</a:t>
-            </a:r>
-          </a:p>
-          <a:p>
-            <a:r>
-              <a:t>it's why today's exercise uses public material.</a:t>
+              <a:t>The three verification instructions, and specifically why the refusal string should be fixed</a:t>
+            </a:r>
+          </a:p>
+          <a:p>
+            <a:r>
+              <a:t>and visible.</a:t>
             </a:r>
           </a:p>
           <a:p/>
           <a:p>
             <a:r>
-              <a:t>"What if the model and my document disagree?" — Excellent question and a good sign. Your</a:t>
-            </a:r>
-          </a:p>
-          <a:p>
-            <a:r>
-              <a:t>document should win — that's the point of grounding — but the disagreement is worth</a:t>
-            </a:r>
-          </a:p>
-          <a:p>
-            <a:r>
-              <a:t>investigating, because it sometimes means your document is out of date.</a:t>
+              <a:t>And the three grounded failure modes by name: answered from memory, retrieved the wrong</a:t>
+            </a:r>
+          </a:p>
+          <a:p>
+            <a:r>
+              <a:t>passage, over-read the passage. I'll give you an answer and a source and ask which one it is.</a:t>
+            </a:r>
+          </a:p>
+          <a:p>
+            <a:r>
+              <a:t>That's a guaranteed exam question, so practise it.</a:t>
             </a:r>
           </a:p>
         </p:txBody>
@@ -2012,6 +2044,289 @@
           <a:p>
             <a:r>
               <a:t>Then you build one.</a:t>
+            </a:r>
+          </a:p>
+        </p:txBody>
+      </p:sp>
+      <p:sp>
+        <p:nvSpPr>
+          <p:cNvPr id="4" name="Slide Number Placeholder 3"/>
+          <p:cNvSpPr>
+            <a:spLocks noGrp="1"/>
+          </p:cNvSpPr>
+          <p:nvPr>
+            <p:ph type="sldNum" idx="5" sz="quarter"/>
+          </p:nvPr>
+        </p:nvSpPr>
+        <p:spPr/>
+      </p:sp>
+    </p:spTree>
+  </p:cSld>
+  <p:clrMapOvr>
+    <a:masterClrMapping/>
+  </p:clrMapOvr>
+</p:notes>
+</file>
+
+<file path=ppt/notesSlides/notesSlide20.xml><?xml version="1.0" encoding="utf-8"?>
+<p:notes xmlns:a="http://schemas.openxmlformats.org/drawingml/2006/main" xmlns:p="http://schemas.openxmlformats.org/presentationml/2006/main" xmlns:r="http://schemas.openxmlformats.org/officeDocument/2006/relationships">
+  <p:cSld>
+    <p:spTree>
+      <p:nvGrpSpPr>
+        <p:cNvPr id="1" name=""/>
+        <p:cNvGrpSpPr/>
+        <p:nvPr/>
+      </p:nvGrpSpPr>
+      <p:grpSpPr>
+        <a:xfrm>
+          <a:off x="0" y="0"/>
+          <a:ext cx="0" cy="0"/>
+          <a:chOff x="0" y="0"/>
+          <a:chExt cx="0" cy="0"/>
+        </a:xfrm>
+      </p:grpSpPr>
+      <p:sp>
+        <p:nvSpPr>
+          <p:cNvPr id="2" name="Slide Image Placeholder 1"/>
+          <p:cNvSpPr>
+            <a:spLocks noGrp="1"/>
+          </p:cNvSpPr>
+          <p:nvPr>
+            <p:ph type="sldImg" idx="2"/>
+          </p:nvPr>
+        </p:nvSpPr>
+        <p:spPr/>
+      </p:sp>
+      <p:sp>
+        <p:nvSpPr>
+          <p:cNvPr id="3" name="Notes Placeholder 2"/>
+          <p:cNvSpPr>
+            <a:spLocks noGrp="1"/>
+          </p:cNvSpPr>
+          <p:nvPr>
+            <p:ph type="body" idx="3" sz="quarter"/>
+          </p:nvPr>
+        </p:nvSpPr>
+        <p:spPr/>
+        <p:txBody>
+          <a:bodyPr/>
+          <a:lstStyle/>
+          <a:p>
+            <a:r>
+              <a:t>Five things.</a:t>
+            </a:r>
+          </a:p>
+          <a:p/>
+          <a:p>
+            <a:r>
+              <a:t>You cannot prompt your way to information the model doesn't have. You have to supply it.</a:t>
+            </a:r>
+          </a:p>
+          <a:p/>
+          <a:p>
+            <a:r>
+              <a:t>Grounding puts your passages into the context at the moment of answering. That's all RAG</a:t>
+            </a:r>
+          </a:p>
+          <a:p>
+            <a:r>
+              <a:t>means, and you should now be immune to people using the acronym to sound impressive.</a:t>
+            </a:r>
+          </a:p>
+          <a:p/>
+          <a:p>
+            <a:r>
+              <a:t>It changes where the answer comes from. It does not install a truth check. Please hold both</a:t>
+            </a:r>
+          </a:p>
+          <a:p>
+            <a:r>
+              <a:t>halves of that sentence.</a:t>
+            </a:r>
+          </a:p>
+          <a:p/>
+          <a:p>
+            <a:r>
+              <a:t>Ask for quotations, and then actually check them — because the quotation marks feel like</a:t>
+            </a:r>
+          </a:p>
+          <a:p>
+            <a:r>
+              <a:t>verification and are not verification.</a:t>
+            </a:r>
+          </a:p>
+          <a:p/>
+          <a:p>
+            <a:r>
+              <a:t>And the three failures: answered from memory, wrong passage, over-read.</a:t>
+            </a:r>
+          </a:p>
+          <a:p/>
+          <a:p>
+            <a:r>
+              <a:t>Next week we do the thing that makes all of this real. You'll build ten questions designed to</a:t>
+            </a:r>
+          </a:p>
+          <a:p>
+            <a:r>
+              <a:t>break what you made today — seven it should answer, and three it cannot possibly answer from</a:t>
+            </a:r>
+          </a:p>
+          <a:p>
+            <a:r>
+              <a:t>your sources. And you'll watch a system you built an hour ago answer those three anyway,</a:t>
+            </a:r>
+          </a:p>
+          <a:p>
+            <a:r>
+              <a:t>confidently.</a:t>
+            </a:r>
+          </a:p>
+          <a:p/>
+          <a:p>
+            <a:r>
+              <a:t>I'd rather you saw that here than discovered it at work.</a:t>
+            </a:r>
+          </a:p>
+          <a:p/>
+          <a:p>
+            <a:r>
+              <a:t>Questions?</a:t>
+            </a:r>
+          </a:p>
+        </p:txBody>
+      </p:sp>
+      <p:sp>
+        <p:nvSpPr>
+          <p:cNvPr id="4" name="Slide Number Placeholder 3"/>
+          <p:cNvSpPr>
+            <a:spLocks noGrp="1"/>
+          </p:cNvSpPr>
+          <p:nvPr>
+            <p:ph type="sldNum" idx="5" sz="quarter"/>
+          </p:nvPr>
+        </p:nvSpPr>
+        <p:spPr/>
+      </p:sp>
+    </p:spTree>
+  </p:cSld>
+  <p:clrMapOvr>
+    <a:masterClrMapping/>
+  </p:clrMapOvr>
+</p:notes>
+</file>
+
+<file path=ppt/notesSlides/notesSlide21.xml><?xml version="1.0" encoding="utf-8"?>
+<p:notes xmlns:a="http://schemas.openxmlformats.org/drawingml/2006/main" xmlns:p="http://schemas.openxmlformats.org/presentationml/2006/main" xmlns:r="http://schemas.openxmlformats.org/officeDocument/2006/relationships">
+  <p:cSld>
+    <p:spTree>
+      <p:nvGrpSpPr>
+        <p:cNvPr id="1" name=""/>
+        <p:cNvGrpSpPr/>
+        <p:nvPr/>
+      </p:nvGrpSpPr>
+      <p:grpSpPr>
+        <a:xfrm>
+          <a:off x="0" y="0"/>
+          <a:ext cx="0" cy="0"/>
+          <a:chOff x="0" y="0"/>
+          <a:chExt cx="0" cy="0"/>
+        </a:xfrm>
+      </p:grpSpPr>
+      <p:sp>
+        <p:nvSpPr>
+          <p:cNvPr id="2" name="Slide Image Placeholder 1"/>
+          <p:cNvSpPr>
+            <a:spLocks noGrp="1"/>
+          </p:cNvSpPr>
+          <p:nvPr>
+            <p:ph type="sldImg" idx="2"/>
+          </p:nvPr>
+        </p:nvSpPr>
+        <p:spPr/>
+      </p:sp>
+      <p:sp>
+        <p:nvSpPr>
+          <p:cNvPr id="3" name="Notes Placeholder 2"/>
+          <p:cNvSpPr>
+            <a:spLocks noGrp="1"/>
+          </p:cNvSpPr>
+          <p:nvPr>
+            <p:ph type="body" idx="3" sz="quarter"/>
+          </p:nvPr>
+        </p:nvSpPr>
+        <p:spPr/>
+        <p:txBody>
+          <a:bodyPr/>
+          <a:lstStyle/>
+          <a:p>
+            <a:r>
+              <a:t>Take questions here.</a:t>
+            </a:r>
+          </a:p>
+          <a:p/>
+          <a:p>
+            <a:r>
+              <a:t>Common ones:</a:t>
+            </a:r>
+          </a:p>
+          <a:p/>
+          <a:p>
+            <a:r>
+              <a:t>"Which tool is best for this?" — Several work well and they change. What matters is that it</a:t>
+            </a:r>
+          </a:p>
+          <a:p>
+            <a:r>
+              <a:t>accepts your documents and lets you ask questions about them. Try two; use whichever handles</a:t>
+            </a:r>
+          </a:p>
+          <a:p>
+            <a:r>
+              <a:t>your file types.</a:t>
+            </a:r>
+          </a:p>
+          <a:p/>
+          <a:p>
+            <a:r>
+              <a:t>"Can I ground it on a website instead of files?" — Often yes. Same principles apply, plus you</a:t>
+            </a:r>
+          </a:p>
+          <a:p>
+            <a:r>
+              <a:t>inherit whatever is wrong on the website, and it may change under you without notice.</a:t>
+            </a:r>
+          </a:p>
+          <a:p/>
+          <a:p>
+            <a:r>
+              <a:t>"Is my document used to train the model?" — Depends entirely on the service and the settings,</a:t>
+            </a:r>
+          </a:p>
+          <a:p>
+            <a:r>
+              <a:t>and it is genuinely worth reading the terms for anything institutional. That's week twelve, and</a:t>
+            </a:r>
+          </a:p>
+          <a:p>
+            <a:r>
+              <a:t>it's why today's exercise uses public material.</a:t>
+            </a:r>
+          </a:p>
+          <a:p/>
+          <a:p>
+            <a:r>
+              <a:t>"What if the model and my document disagree?" — Excellent question and a good sign. Your</a:t>
+            </a:r>
+          </a:p>
+          <a:p>
+            <a:r>
+              <a:t>document should win — that's the point of grounding — but the disagreement is worth</a:t>
+            </a:r>
+          </a:p>
+          <a:p>
+            <a:r>
+              <a:t>investigating, because it sometimes means your document is out of date.</a:t>
             </a:r>
           </a:p>
         </p:txBody>
@@ -6998,7 +7313,7 @@
                 </a:solidFill>
                 <a:latin typeface="Calibri Light"/>
               </a:rPr>
-              <a:t>Three Ways a Grounded Answer Goes Wrong</a:t>
+              <a:t>The Three Instructions in Action</a:t>
             </a:r>
           </a:p>
         </p:txBody>
@@ -7049,542 +7364,14 @@
       </p:sp>
       <p:sp>
         <p:nvSpPr>
-          <p:cNvPr id="4" name="Rounded Rectangle 3"/>
-          <p:cNvSpPr/>
-          <p:nvPr/>
-        </p:nvSpPr>
-        <p:spPr>
-          <a:xfrm>
-            <a:off x="777240" y="2057400"/>
-            <a:ext cx="3301898" cy="3200400"/>
-          </a:xfrm>
-          <a:prstGeom prst="roundRect">
-            <a:avLst>
-              <a:gd name="adj" fmla="val 10000"/>
-            </a:avLst>
-          </a:prstGeom>
-          <a:solidFill>
-            <a:srgbClr val="F1F5F9"/>
-          </a:solidFill>
-          <a:ln w="15875">
-            <a:solidFill>
-              <a:srgbClr val="D3DDE6"/>
-            </a:solidFill>
-          </a:ln>
-          <a:effectLst/>
-        </p:spPr>
-        <p:style>
-          <a:lnRef idx="1">
-            <a:schemeClr val="accent1"/>
-          </a:lnRef>
-          <a:fillRef idx="3">
-            <a:schemeClr val="accent1"/>
-          </a:fillRef>
-          <a:effectRef idx="2">
-            <a:schemeClr val="accent1"/>
-          </a:effectRef>
-          <a:fontRef idx="minor">
-            <a:schemeClr val="lt1"/>
-          </a:fontRef>
-        </p:style>
-        <p:txBody>
-          <a:bodyPr rtlCol="0" anchor="ctr"/>
-          <a:lstStyle/>
-          <a:p>
-            <a:pPr algn="ctr"/>
-          </a:p>
-        </p:txBody>
-      </p:sp>
-      <p:sp>
-        <p:nvSpPr>
-          <p:cNvPr id="5" name="Rectangle 4"/>
-          <p:cNvSpPr/>
-          <p:nvPr/>
-        </p:nvSpPr>
-        <p:spPr>
-          <a:xfrm>
-            <a:off x="978408" y="2331720"/>
-            <a:ext cx="640080" cy="38100"/>
-          </a:xfrm>
-          <a:prstGeom prst="rect">
-            <a:avLst/>
-          </a:prstGeom>
-          <a:solidFill>
-            <a:srgbClr val="0F766E"/>
-          </a:solidFill>
-          <a:ln>
-            <a:noFill/>
-          </a:ln>
-          <a:effectLst/>
-        </p:spPr>
-        <p:style>
-          <a:lnRef idx="1">
-            <a:schemeClr val="accent1"/>
-          </a:lnRef>
-          <a:fillRef idx="3">
-            <a:schemeClr val="accent1"/>
-          </a:fillRef>
-          <a:effectRef idx="2">
-            <a:schemeClr val="accent1"/>
-          </a:effectRef>
-          <a:fontRef idx="minor">
-            <a:schemeClr val="lt1"/>
-          </a:fontRef>
-        </p:style>
-        <p:txBody>
-          <a:bodyPr rtlCol="0" anchor="ctr"/>
-          <a:lstStyle/>
-          <a:p>
-            <a:pPr algn="ctr"/>
-          </a:p>
-        </p:txBody>
-      </p:sp>
-      <p:sp>
-        <p:nvSpPr>
-          <p:cNvPr id="6" name="TextBox 5"/>
+          <p:cNvPr id="4" name="TextBox 3"/>
           <p:cNvSpPr txBox="1"/>
           <p:nvPr/>
         </p:nvSpPr>
         <p:spPr>
           <a:xfrm>
-            <a:off x="978408" y="2560320"/>
-            <a:ext cx="2899562" cy="640080"/>
-          </a:xfrm>
-          <a:prstGeom prst="rect">
-            <a:avLst/>
-          </a:prstGeom>
-          <a:noFill/>
-        </p:spPr>
-        <p:txBody>
-          <a:bodyPr wrap="square" lIns="0" rIns="0" tIns="0" bIns="0" anchor="t">
-            <a:spAutoFit/>
-          </a:bodyPr>
-          <a:lstStyle/>
-          <a:p>
-            <a:pPr algn="l">
-              <a:lnSpc>
-                <a:spcPct val="105000"/>
-              </a:lnSpc>
-              <a:spcAft>
-                <a:spcPts val="200"/>
-              </a:spcAft>
-            </a:pPr>
-            <a:r>
-              <a:rPr sz="1800" b="1" i="0">
-                <a:solidFill>
-                  <a:srgbClr val="1F2937"/>
-                </a:solidFill>
-                <a:latin typeface="Calibri"/>
-              </a:rPr>
-              <a:t>Answered from memory</a:t>
-            </a:r>
-          </a:p>
-        </p:txBody>
-      </p:sp>
-      <p:sp>
-        <p:nvSpPr>
-          <p:cNvPr id="7" name="TextBox 6"/>
-          <p:cNvSpPr txBox="1"/>
-          <p:nvPr/>
-        </p:nvSpPr>
-        <p:spPr>
-          <a:xfrm>
-            <a:off x="978408" y="3246120"/>
-            <a:ext cx="2899562" cy="1737360"/>
-          </a:xfrm>
-          <a:prstGeom prst="rect">
-            <a:avLst/>
-          </a:prstGeom>
-          <a:noFill/>
-        </p:spPr>
-        <p:txBody>
-          <a:bodyPr wrap="square" lIns="0" rIns="0" tIns="0" bIns="0" anchor="t">
-            <a:spAutoFit/>
-          </a:bodyPr>
-          <a:lstStyle/>
-          <a:p>
-            <a:pPr algn="l">
-              <a:lnSpc>
-                <a:spcPct val="105000"/>
-              </a:lnSpc>
-              <a:spcAft>
-                <a:spcPts val="200"/>
-              </a:spcAft>
-            </a:pPr>
-            <a:r>
-              <a:rPr sz="1350" b="0" i="0">
-                <a:solidFill>
-                  <a:srgbClr val="333D4B"/>
-                </a:solidFill>
-                <a:latin typeface="Calibri"/>
-              </a:rPr>
-              <a:t>Your documents did not contain it. The model knew something adjacent and used that instead. Detect it: the answer has no quotation, or a vague one.</a:t>
-            </a:r>
-          </a:p>
-        </p:txBody>
-      </p:sp>
-      <p:sp>
-        <p:nvSpPr>
-          <p:cNvPr id="8" name="Rounded Rectangle 7"/>
-          <p:cNvSpPr/>
-          <p:nvPr/>
-        </p:nvSpPr>
-        <p:spPr>
-          <a:xfrm>
-            <a:off x="4444898" y="2057400"/>
-            <a:ext cx="3301898" cy="3200400"/>
-          </a:xfrm>
-          <a:prstGeom prst="roundRect">
-            <a:avLst>
-              <a:gd name="adj" fmla="val 10000"/>
-            </a:avLst>
-          </a:prstGeom>
-          <a:solidFill>
-            <a:srgbClr val="F1F5F9"/>
-          </a:solidFill>
-          <a:ln w="15875">
-            <a:solidFill>
-              <a:srgbClr val="D3DDE6"/>
-            </a:solidFill>
-          </a:ln>
-          <a:effectLst/>
-        </p:spPr>
-        <p:style>
-          <a:lnRef idx="1">
-            <a:schemeClr val="accent1"/>
-          </a:lnRef>
-          <a:fillRef idx="3">
-            <a:schemeClr val="accent1"/>
-          </a:fillRef>
-          <a:effectRef idx="2">
-            <a:schemeClr val="accent1"/>
-          </a:effectRef>
-          <a:fontRef idx="minor">
-            <a:schemeClr val="lt1"/>
-          </a:fontRef>
-        </p:style>
-        <p:txBody>
-          <a:bodyPr rtlCol="0" anchor="ctr"/>
-          <a:lstStyle/>
-          <a:p>
-            <a:pPr algn="ctr"/>
-          </a:p>
-        </p:txBody>
-      </p:sp>
-      <p:sp>
-        <p:nvSpPr>
-          <p:cNvPr id="9" name="Rectangle 8"/>
-          <p:cNvSpPr/>
-          <p:nvPr/>
-        </p:nvSpPr>
-        <p:spPr>
-          <a:xfrm>
-            <a:off x="4646066" y="2331720"/>
-            <a:ext cx="640080" cy="38100"/>
-          </a:xfrm>
-          <a:prstGeom prst="rect">
-            <a:avLst/>
-          </a:prstGeom>
-          <a:solidFill>
-            <a:srgbClr val="0F766E"/>
-          </a:solidFill>
-          <a:ln>
-            <a:noFill/>
-          </a:ln>
-          <a:effectLst/>
-        </p:spPr>
-        <p:style>
-          <a:lnRef idx="1">
-            <a:schemeClr val="accent1"/>
-          </a:lnRef>
-          <a:fillRef idx="3">
-            <a:schemeClr val="accent1"/>
-          </a:fillRef>
-          <a:effectRef idx="2">
-            <a:schemeClr val="accent1"/>
-          </a:effectRef>
-          <a:fontRef idx="minor">
-            <a:schemeClr val="lt1"/>
-          </a:fontRef>
-        </p:style>
-        <p:txBody>
-          <a:bodyPr rtlCol="0" anchor="ctr"/>
-          <a:lstStyle/>
-          <a:p>
-            <a:pPr algn="ctr"/>
-          </a:p>
-        </p:txBody>
-      </p:sp>
-      <p:sp>
-        <p:nvSpPr>
-          <p:cNvPr id="10" name="TextBox 9"/>
-          <p:cNvSpPr txBox="1"/>
-          <p:nvPr/>
-        </p:nvSpPr>
-        <p:spPr>
-          <a:xfrm>
-            <a:off x="4646066" y="2560320"/>
-            <a:ext cx="2899562" cy="640080"/>
-          </a:xfrm>
-          <a:prstGeom prst="rect">
-            <a:avLst/>
-          </a:prstGeom>
-          <a:noFill/>
-        </p:spPr>
-        <p:txBody>
-          <a:bodyPr wrap="square" lIns="0" rIns="0" tIns="0" bIns="0" anchor="t">
-            <a:spAutoFit/>
-          </a:bodyPr>
-          <a:lstStyle/>
-          <a:p>
-            <a:pPr algn="l">
-              <a:lnSpc>
-                <a:spcPct val="105000"/>
-              </a:lnSpc>
-              <a:spcAft>
-                <a:spcPts val="200"/>
-              </a:spcAft>
-            </a:pPr>
-            <a:r>
-              <a:rPr sz="1800" b="1" i="0">
-                <a:solidFill>
-                  <a:srgbClr val="1F2937"/>
-                </a:solidFill>
-                <a:latin typeface="Calibri"/>
-              </a:rPr>
-              <a:t>Retrieved the wrong passage</a:t>
-            </a:r>
-          </a:p>
-        </p:txBody>
-      </p:sp>
-      <p:sp>
-        <p:nvSpPr>
-          <p:cNvPr id="11" name="TextBox 10"/>
-          <p:cNvSpPr txBox="1"/>
-          <p:nvPr/>
-        </p:nvSpPr>
-        <p:spPr>
-          <a:xfrm>
-            <a:off x="4646066" y="3246120"/>
-            <a:ext cx="2899562" cy="1737360"/>
-          </a:xfrm>
-          <a:prstGeom prst="rect">
-            <a:avLst/>
-          </a:prstGeom>
-          <a:noFill/>
-        </p:spPr>
-        <p:txBody>
-          <a:bodyPr wrap="square" lIns="0" rIns="0" tIns="0" bIns="0" anchor="t">
-            <a:spAutoFit/>
-          </a:bodyPr>
-          <a:lstStyle/>
-          <a:p>
-            <a:pPr algn="l">
-              <a:lnSpc>
-                <a:spcPct val="105000"/>
-              </a:lnSpc>
-              <a:spcAft>
-                <a:spcPts val="200"/>
-              </a:spcAft>
-            </a:pPr>
-            <a:r>
-              <a:rPr sz="1350" b="0" i="0">
-                <a:solidFill>
-                  <a:srgbClr val="333D4B"/>
-                </a:solidFill>
-                <a:latin typeface="Calibri"/>
-              </a:rPr>
-              <a:t>The right words appeared somewhere unrelated. The quotation is genuine and the conclusion is wrong. Detect it: read the quoted passage in its original context.</a:t>
-            </a:r>
-          </a:p>
-        </p:txBody>
-      </p:sp>
-      <p:sp>
-        <p:nvSpPr>
-          <p:cNvPr id="12" name="Rounded Rectangle 11"/>
-          <p:cNvSpPr/>
-          <p:nvPr/>
-        </p:nvSpPr>
-        <p:spPr>
-          <a:xfrm>
-            <a:off x="8112556" y="2057400"/>
-            <a:ext cx="3301898" cy="3200400"/>
-          </a:xfrm>
-          <a:prstGeom prst="roundRect">
-            <a:avLst>
-              <a:gd name="adj" fmla="val 10000"/>
-            </a:avLst>
-          </a:prstGeom>
-          <a:solidFill>
-            <a:srgbClr val="F1F5F9"/>
-          </a:solidFill>
-          <a:ln w="15875">
-            <a:solidFill>
-              <a:srgbClr val="D3DDE6"/>
-            </a:solidFill>
-          </a:ln>
-          <a:effectLst/>
-        </p:spPr>
-        <p:style>
-          <a:lnRef idx="1">
-            <a:schemeClr val="accent1"/>
-          </a:lnRef>
-          <a:fillRef idx="3">
-            <a:schemeClr val="accent1"/>
-          </a:fillRef>
-          <a:effectRef idx="2">
-            <a:schemeClr val="accent1"/>
-          </a:effectRef>
-          <a:fontRef idx="minor">
-            <a:schemeClr val="lt1"/>
-          </a:fontRef>
-        </p:style>
-        <p:txBody>
-          <a:bodyPr rtlCol="0" anchor="ctr"/>
-          <a:lstStyle/>
-          <a:p>
-            <a:pPr algn="ctr"/>
-          </a:p>
-        </p:txBody>
-      </p:sp>
-      <p:sp>
-        <p:nvSpPr>
-          <p:cNvPr id="13" name="Rectangle 12"/>
-          <p:cNvSpPr/>
-          <p:nvPr/>
-        </p:nvSpPr>
-        <p:spPr>
-          <a:xfrm>
-            <a:off x="8313724" y="2331720"/>
-            <a:ext cx="640080" cy="38100"/>
-          </a:xfrm>
-          <a:prstGeom prst="rect">
-            <a:avLst/>
-          </a:prstGeom>
-          <a:solidFill>
-            <a:srgbClr val="0F766E"/>
-          </a:solidFill>
-          <a:ln>
-            <a:noFill/>
-          </a:ln>
-          <a:effectLst/>
-        </p:spPr>
-        <p:style>
-          <a:lnRef idx="1">
-            <a:schemeClr val="accent1"/>
-          </a:lnRef>
-          <a:fillRef idx="3">
-            <a:schemeClr val="accent1"/>
-          </a:fillRef>
-          <a:effectRef idx="2">
-            <a:schemeClr val="accent1"/>
-          </a:effectRef>
-          <a:fontRef idx="minor">
-            <a:schemeClr val="lt1"/>
-          </a:fontRef>
-        </p:style>
-        <p:txBody>
-          <a:bodyPr rtlCol="0" anchor="ctr"/>
-          <a:lstStyle/>
-          <a:p>
-            <a:pPr algn="ctr"/>
-          </a:p>
-        </p:txBody>
-      </p:sp>
-      <p:sp>
-        <p:nvSpPr>
-          <p:cNvPr id="14" name="TextBox 13"/>
-          <p:cNvSpPr txBox="1"/>
-          <p:nvPr/>
-        </p:nvSpPr>
-        <p:spPr>
-          <a:xfrm>
-            <a:off x="8313724" y="2560320"/>
-            <a:ext cx="2899562" cy="640080"/>
-          </a:xfrm>
-          <a:prstGeom prst="rect">
-            <a:avLst/>
-          </a:prstGeom>
-          <a:noFill/>
-        </p:spPr>
-        <p:txBody>
-          <a:bodyPr wrap="square" lIns="0" rIns="0" tIns="0" bIns="0" anchor="t">
-            <a:spAutoFit/>
-          </a:bodyPr>
-          <a:lstStyle/>
-          <a:p>
-            <a:pPr algn="l">
-              <a:lnSpc>
-                <a:spcPct val="105000"/>
-              </a:lnSpc>
-              <a:spcAft>
-                <a:spcPts val="200"/>
-              </a:spcAft>
-            </a:pPr>
-            <a:r>
-              <a:rPr sz="1800" b="1" i="0">
-                <a:solidFill>
-                  <a:srgbClr val="1F2937"/>
-                </a:solidFill>
-                <a:latin typeface="Calibri"/>
-              </a:rPr>
-              <a:t>Over-read the passage</a:t>
-            </a:r>
-          </a:p>
-        </p:txBody>
-      </p:sp>
-      <p:sp>
-        <p:nvSpPr>
-          <p:cNvPr id="15" name="TextBox 14"/>
-          <p:cNvSpPr txBox="1"/>
-          <p:nvPr/>
-        </p:nvSpPr>
-        <p:spPr>
-          <a:xfrm>
-            <a:off x="8313724" y="3246120"/>
-            <a:ext cx="2899562" cy="1737360"/>
-          </a:xfrm>
-          <a:prstGeom prst="rect">
-            <a:avLst/>
-          </a:prstGeom>
-          <a:noFill/>
-        </p:spPr>
-        <p:txBody>
-          <a:bodyPr wrap="square" lIns="0" rIns="0" tIns="0" bIns="0" anchor="t">
-            <a:spAutoFit/>
-          </a:bodyPr>
-          <a:lstStyle/>
-          <a:p>
-            <a:pPr algn="l">
-              <a:lnSpc>
-                <a:spcPct val="105000"/>
-              </a:lnSpc>
-              <a:spcAft>
-                <a:spcPts val="200"/>
-              </a:spcAft>
-            </a:pPr>
-            <a:r>
-              <a:rPr sz="1350" b="0" i="0">
-                <a:solidFill>
-                  <a:srgbClr val="333D4B"/>
-                </a:solidFill>
-                <a:latin typeface="Calibri"/>
-              </a:rPr>
-              <a:t>The source says something narrower than the answer claims. "May" becomes "must". An example becomes a rule. Detect it: compare the strength of the claim with the strength of the quote.</a:t>
-            </a:r>
-          </a:p>
-        </p:txBody>
-      </p:sp>
-      <p:sp>
-        <p:nvSpPr>
-          <p:cNvPr id="16" name="TextBox 15"/>
-          <p:cNvSpPr txBox="1"/>
-          <p:nvPr/>
-        </p:nvSpPr>
-        <p:spPr>
-          <a:xfrm>
-            <a:off x="777240" y="6355080"/>
-            <a:ext cx="10637215" cy="274320"/>
+            <a:off x="777240" y="1783080"/>
+            <a:ext cx="10637215" cy="4343400"/>
           </a:xfrm>
           <a:prstGeom prst="rect">
             <a:avLst/>
@@ -7597,6 +7384,201 @@
           </a:bodyPr>
           <a:lstStyle/>
           <a:p>
+            <a:pPr>
+              <a:lnSpc>
+                <a:spcPct val="115000"/>
+              </a:lnSpc>
+              <a:spcAft>
+                <a:spcPts val="1000"/>
+              </a:spcAft>
+            </a:pPr>
+            <a:r>
+              <a:rPr sz="1900" b="1" i="0">
+                <a:solidFill>
+                  <a:srgbClr val="1F2937"/>
+                </a:solidFill>
+                <a:latin typeface="Calibri"/>
+              </a:rPr>
+              <a:t>•  Question:</a:t>
+            </a:r>
+          </a:p>
+          <a:p>
+            <a:pPr lvl="1">
+              <a:lnSpc>
+                <a:spcPct val="115000"/>
+              </a:lnSpc>
+              <a:spcAft>
+                <a:spcPts val="500"/>
+              </a:spcAft>
+            </a:pPr>
+            <a:r>
+              <a:rPr sz="1600" b="0" i="0">
+                <a:solidFill>
+                  <a:srgbClr val="333D4B"/>
+                </a:solidFill>
+                <a:latin typeface="Calibri"/>
+              </a:rPr>
+              <a:t>—  "What is the maximum period for submitting an appeal?"</a:t>
+            </a:r>
+          </a:p>
+          <a:p>
+            <a:pPr>
+              <a:lnSpc>
+                <a:spcPct val="115000"/>
+              </a:lnSpc>
+              <a:spcAft>
+                <a:spcPts val="1000"/>
+              </a:spcAft>
+            </a:pPr>
+          </a:p>
+          <a:p>
+            <a:pPr>
+              <a:lnSpc>
+                <a:spcPct val="115000"/>
+              </a:lnSpc>
+              <a:spcAft>
+                <a:spcPts val="1000"/>
+              </a:spcAft>
+            </a:pPr>
+            <a:r>
+              <a:rPr sz="1900" b="1" i="0">
+                <a:solidFill>
+                  <a:srgbClr val="1F2937"/>
+                </a:solidFill>
+                <a:latin typeface="Calibri"/>
+              </a:rPr>
+              <a:t>•  A good answer looks like this:</a:t>
+            </a:r>
+          </a:p>
+          <a:p>
+            <a:pPr lvl="1">
+              <a:lnSpc>
+                <a:spcPct val="115000"/>
+              </a:lnSpc>
+              <a:spcAft>
+                <a:spcPts val="500"/>
+              </a:spcAft>
+            </a:pPr>
+            <a:r>
+              <a:rPr sz="1600" b="0" i="0">
+                <a:solidFill>
+                  <a:srgbClr val="333D4B"/>
+                </a:solidFill>
+                <a:latin typeface="Calibri"/>
+              </a:rPr>
+              <a:t>—  "Fifteen working days from the date of notification."</a:t>
+            </a:r>
+          </a:p>
+          <a:p>
+            <a:pPr lvl="1">
+              <a:lnSpc>
+                <a:spcPct val="115000"/>
+              </a:lnSpc>
+              <a:spcAft>
+                <a:spcPts val="500"/>
+              </a:spcAft>
+            </a:pPr>
+            <a:r>
+              <a:rPr sz="1600" b="0" i="0">
+                <a:solidFill>
+                  <a:srgbClr val="333D4B"/>
+                </a:solidFill>
+                <a:latin typeface="Calibri"/>
+              </a:rPr>
+              <a:t>—  "Source: 'An appeal shall be lodged within fifteen (15) working days of the date on which the decision is notified.' (Regulation 8.2)"</a:t>
+            </a:r>
+          </a:p>
+          <a:p>
+            <a:pPr>
+              <a:lnSpc>
+                <a:spcPct val="115000"/>
+              </a:lnSpc>
+              <a:spcAft>
+                <a:spcPts val="1000"/>
+              </a:spcAft>
+            </a:pPr>
+          </a:p>
+          <a:p>
+            <a:pPr>
+              <a:lnSpc>
+                <a:spcPct val="115000"/>
+              </a:lnSpc>
+              <a:spcAft>
+                <a:spcPts val="1000"/>
+              </a:spcAft>
+            </a:pPr>
+            <a:r>
+              <a:rPr sz="1900" b="1" i="0">
+                <a:solidFill>
+                  <a:srgbClr val="1F2937"/>
+                </a:solidFill>
+                <a:latin typeface="Calibri"/>
+              </a:rPr>
+              <a:t>•  A bad answer looks like this:</a:t>
+            </a:r>
+          </a:p>
+          <a:p>
+            <a:pPr lvl="1">
+              <a:lnSpc>
+                <a:spcPct val="115000"/>
+              </a:lnSpc>
+              <a:spcAft>
+                <a:spcPts val="500"/>
+              </a:spcAft>
+            </a:pPr>
+            <a:r>
+              <a:rPr sz="1600" b="0" i="0">
+                <a:solidFill>
+                  <a:srgbClr val="333D4B"/>
+                </a:solidFill>
+                <a:latin typeface="Calibri"/>
+              </a:rPr>
+              <a:t>—  "Appeals are generally expected to be submitted promptly, typically within two to four weeks of the decision."</a:t>
+            </a:r>
+          </a:p>
+          <a:p>
+            <a:pPr lvl="1">
+              <a:lnSpc>
+                <a:spcPct val="115000"/>
+              </a:lnSpc>
+              <a:spcAft>
+                <a:spcPts val="500"/>
+              </a:spcAft>
+            </a:pPr>
+            <a:r>
+              <a:rPr sz="1600" b="0" i="0">
+                <a:solidFill>
+                  <a:srgbClr val="333D4B"/>
+                </a:solidFill>
+                <a:latin typeface="Calibri"/>
+              </a:rPr>
+              <a:t>—  No quotation. No clause. Hedged language. Nothing you can check.</a:t>
+            </a:r>
+          </a:p>
+        </p:txBody>
+      </p:sp>
+      <p:sp>
+        <p:nvSpPr>
+          <p:cNvPr id="5" name="TextBox 4"/>
+          <p:cNvSpPr txBox="1"/>
+          <p:nvPr/>
+        </p:nvSpPr>
+        <p:spPr>
+          <a:xfrm>
+            <a:off x="777240" y="6355080"/>
+            <a:ext cx="10637215" cy="274320"/>
+          </a:xfrm>
+          <a:prstGeom prst="rect">
+            <a:avLst/>
+          </a:prstGeom>
+          <a:noFill/>
+        </p:spPr>
+        <p:txBody>
+          <a:bodyPr wrap="square" lIns="0" rIns="0" tIns="0" bIns="0">
+            <a:spAutoFit/>
+          </a:bodyPr>
+          <a:lstStyle/>
+          <a:p>
             <a:r>
               <a:rPr sz="1000" b="0" i="0">
                 <a:solidFill>
@@ -7611,7 +7593,7 @@
       </p:sp>
       <p:sp>
         <p:nvSpPr>
-          <p:cNvPr id="17" name="TextBox 16"/>
+          <p:cNvPr id="6" name="TextBox 5"/>
           <p:cNvSpPr txBox="1"/>
           <p:nvPr/>
         </p:nvSpPr>
@@ -7664,14 +7646,48 @@
       <p:grpSpPr/>
       <p:sp>
         <p:nvSpPr>
-          <p:cNvPr id="2" name="Rectangle 1"/>
+          <p:cNvPr id="2" name="TextBox 1"/>
+          <p:cNvSpPr txBox="1"/>
+          <p:nvPr/>
+        </p:nvSpPr>
+        <p:spPr>
+          <a:xfrm>
+            <a:off x="777240" y="566928"/>
+            <a:ext cx="10637215" cy="822960"/>
+          </a:xfrm>
+          <a:prstGeom prst="rect">
+            <a:avLst/>
+          </a:prstGeom>
+          <a:noFill/>
+        </p:spPr>
+        <p:txBody>
+          <a:bodyPr wrap="square" lIns="0" rIns="0" tIns="0" bIns="0">
+            <a:spAutoFit/>
+          </a:bodyPr>
+          <a:lstStyle/>
+          <a:p>
+            <a:r>
+              <a:rPr sz="3000" b="1" i="0">
+                <a:solidFill>
+                  <a:srgbClr val="1F2937"/>
+                </a:solidFill>
+                <a:latin typeface="Calibri Light"/>
+              </a:rPr>
+              <a:t>Preparing Documents So Retrieval Works</a:t>
+            </a:r>
+          </a:p>
+        </p:txBody>
+      </p:sp>
+      <p:sp>
+        <p:nvSpPr>
+          <p:cNvPr id="3" name="Rectangle 2"/>
           <p:cNvSpPr/>
           <p:nvPr/>
         </p:nvSpPr>
         <p:spPr>
           <a:xfrm>
-            <a:off x="0" y="0"/>
-            <a:ext cx="292608" cy="6858000"/>
+            <a:off x="777240" y="1417320"/>
+            <a:ext cx="1051560" cy="38100"/>
           </a:xfrm>
           <a:prstGeom prst="rect">
             <a:avLst/>
@@ -7708,14 +7724,14 @@
       </p:sp>
       <p:sp>
         <p:nvSpPr>
-          <p:cNvPr id="3" name="TextBox 2"/>
+          <p:cNvPr id="4" name="TextBox 3"/>
           <p:cNvSpPr txBox="1"/>
           <p:nvPr/>
         </p:nvSpPr>
         <p:spPr>
           <a:xfrm>
-            <a:off x="1280160" y="2743200"/>
-            <a:ext cx="10058400" cy="457200"/>
+            <a:off x="777240" y="1783080"/>
+            <a:ext cx="10637215" cy="4343400"/>
           </a:xfrm>
           <a:prstGeom prst="rect">
             <a:avLst/>
@@ -7728,28 +7744,151 @@
           </a:bodyPr>
           <a:lstStyle/>
           <a:p>
-            <a:r>
-              <a:rPr sz="1400" b="1" i="0">
-                <a:solidFill>
-                  <a:srgbClr val="0F766E"/>
-                </a:solidFill>
-                <a:latin typeface="Calibri"/>
-              </a:rPr>
-              <a:t>PART 4</a:t>
-            </a:r>
-          </a:p>
-        </p:txBody>
-      </p:sp>
-      <p:sp>
-        <p:nvSpPr>
-          <p:cNvPr id="4" name="TextBox 3"/>
+            <a:pPr>
+              <a:lnSpc>
+                <a:spcPct val="115000"/>
+              </a:lnSpc>
+              <a:spcAft>
+                <a:spcPts val="1000"/>
+              </a:spcAft>
+            </a:pPr>
+            <a:r>
+              <a:rPr sz="1900" b="0" i="0">
+                <a:solidFill>
+                  <a:srgbClr val="1F2937"/>
+                </a:solidFill>
+                <a:latin typeface="Calibri"/>
+              </a:rPr>
+              <a:t>•  Fifteen minutes of preparation buys more than any amount of prompt rewriting</a:t>
+            </a:r>
+          </a:p>
+          <a:p>
+            <a:pPr>
+              <a:lnSpc>
+                <a:spcPct val="115000"/>
+              </a:lnSpc>
+              <a:spcAft>
+                <a:spcPts val="1000"/>
+              </a:spcAft>
+            </a:pPr>
+          </a:p>
+          <a:p>
+            <a:pPr lvl="1">
+              <a:lnSpc>
+                <a:spcPct val="115000"/>
+              </a:lnSpc>
+              <a:spcAft>
+                <a:spcPts val="500"/>
+              </a:spcAft>
+            </a:pPr>
+            <a:r>
+              <a:rPr sz="1600" b="0" i="0">
+                <a:solidFill>
+                  <a:srgbClr val="333D4B"/>
+                </a:solidFill>
+                <a:latin typeface="Calibri"/>
+              </a:rPr>
+              <a:t>—  Split a long document into sections of roughly one topic each, with descriptive headings</a:t>
+            </a:r>
+          </a:p>
+          <a:p>
+            <a:pPr lvl="1">
+              <a:lnSpc>
+                <a:spcPct val="115000"/>
+              </a:lnSpc>
+              <a:spcAft>
+                <a:spcPts val="500"/>
+              </a:spcAft>
+            </a:pPr>
+            <a:r>
+              <a:rPr sz="1600" b="0" i="0">
+                <a:solidFill>
+                  <a:srgbClr val="333D4B"/>
+                </a:solidFill>
+                <a:latin typeface="Calibri"/>
+              </a:rPr>
+              <a:t>—  Replace "as described above" and "see section 3" with the actual content, where you can</a:t>
+            </a:r>
+          </a:p>
+          <a:p>
+            <a:pPr lvl="1">
+              <a:lnSpc>
+                <a:spcPct val="115000"/>
+              </a:lnSpc>
+              <a:spcAft>
+                <a:spcPts val="500"/>
+              </a:spcAft>
+            </a:pPr>
+            <a:r>
+              <a:rPr sz="1600" b="0" i="0">
+                <a:solidFill>
+                  <a:srgbClr val="333D4B"/>
+                </a:solidFill>
+                <a:latin typeface="Calibri"/>
+              </a:rPr>
+              <a:t>—  Convert scanned pages to real text — otherwise nothing is retrievable at all</a:t>
+            </a:r>
+          </a:p>
+          <a:p>
+            <a:pPr lvl="1">
+              <a:lnSpc>
+                <a:spcPct val="115000"/>
+              </a:lnSpc>
+              <a:spcAft>
+                <a:spcPts val="500"/>
+              </a:spcAft>
+            </a:pPr>
+            <a:r>
+              <a:rPr sz="1600" b="0" i="0">
+                <a:solidFill>
+                  <a:srgbClr val="333D4B"/>
+                </a:solidFill>
+                <a:latin typeface="Calibri"/>
+              </a:rPr>
+              <a:t>—  Delete material irrelevant to the questions you will ask; it competes for retrieval</a:t>
+            </a:r>
+          </a:p>
+          <a:p>
+            <a:pPr>
+              <a:lnSpc>
+                <a:spcPct val="115000"/>
+              </a:lnSpc>
+              <a:spcAft>
+                <a:spcPts val="1000"/>
+              </a:spcAft>
+            </a:pPr>
+          </a:p>
+          <a:p>
+            <a:pPr>
+              <a:lnSpc>
+                <a:spcPct val="115000"/>
+              </a:lnSpc>
+              <a:spcAft>
+                <a:spcPts val="1000"/>
+              </a:spcAft>
+            </a:pPr>
+            <a:r>
+              <a:rPr sz="1900" b="1" i="0">
+                <a:solidFill>
+                  <a:srgbClr val="1F2937"/>
+                </a:solidFill>
+                <a:latin typeface="Calibri"/>
+              </a:rPr>
+              <a:t>•  Then re-run the same questions and compare. This is the fastest improvement available to you.</a:t>
+            </a:r>
+          </a:p>
+        </p:txBody>
+      </p:sp>
+      <p:sp>
+        <p:nvSpPr>
+          <p:cNvPr id="5" name="TextBox 4"/>
           <p:cNvSpPr txBox="1"/>
           <p:nvPr/>
         </p:nvSpPr>
         <p:spPr>
           <a:xfrm>
-            <a:off x="1280160" y="3200400"/>
-            <a:ext cx="10058400" cy="1097280"/>
+            <a:off x="777240" y="6355080"/>
+            <a:ext cx="10637215" cy="274320"/>
           </a:xfrm>
           <a:prstGeom prst="rect">
             <a:avLst/>
@@ -7763,13 +7902,48 @@
           <a:lstStyle/>
           <a:p>
             <a:r>
-              <a:rPr sz="3400" b="1" i="0">
-                <a:solidFill>
-                  <a:srgbClr val="1F2937"/>
-                </a:solidFill>
-                <a:latin typeface="Calibri Light"/>
-              </a:rPr>
-              <a:t>Build</a:t>
+              <a:rPr sz="1000" b="0" i="0">
+                <a:solidFill>
+                  <a:srgbClr val="6B7787"/>
+                </a:solidFill>
+                <a:latin typeface="Calibri"/>
+              </a:rPr>
+              <a:t>Week 7  ·  Prompt Engineering and Large Language Models</a:t>
+            </a:r>
+          </a:p>
+        </p:txBody>
+      </p:sp>
+      <p:sp>
+        <p:nvSpPr>
+          <p:cNvPr id="6" name="TextBox 5"/>
+          <p:cNvSpPr txBox="1"/>
+          <p:nvPr/>
+        </p:nvSpPr>
+        <p:spPr>
+          <a:xfrm>
+            <a:off x="10500055" y="6355080"/>
+            <a:ext cx="914400" cy="274320"/>
+          </a:xfrm>
+          <a:prstGeom prst="rect">
+            <a:avLst/>
+          </a:prstGeom>
+          <a:noFill/>
+        </p:spPr>
+        <p:txBody>
+          <a:bodyPr wrap="square" lIns="0" rIns="0" tIns="0" bIns="0">
+            <a:spAutoFit/>
+          </a:bodyPr>
+          <a:lstStyle/>
+          <a:p>
+            <a:pPr algn="r"/>
+            <a:r>
+              <a:rPr sz="1000" b="0" i="0">
+                <a:solidFill>
+                  <a:srgbClr val="6B7787"/>
+                </a:solidFill>
+                <a:latin typeface="Calibri"/>
+              </a:rPr>
+              <a:t>14</a:t>
             </a:r>
           </a:p>
         </p:txBody>
@@ -7801,7 +7975,7 @@
         <p:spPr>
           <a:xfrm>
             <a:off x="777240" y="566928"/>
-            <a:ext cx="10637215" cy="365760"/>
+            <a:ext cx="10637215" cy="822960"/>
           </a:xfrm>
           <a:prstGeom prst="rect">
             <a:avLst/>
@@ -7815,67 +7989,33 @@
           <a:lstStyle/>
           <a:p>
             <a:r>
-              <a:rPr sz="1300" b="1" i="0">
-                <a:solidFill>
-                  <a:srgbClr val="B45309"/>
-                </a:solidFill>
-                <a:latin typeface="Calibri"/>
-              </a:rPr>
-              <a:t>IN-CLASS ACTIVITY  ·  20 MINUTES</a:t>
-            </a:r>
-          </a:p>
-        </p:txBody>
-      </p:sp>
-      <p:sp>
-        <p:nvSpPr>
-          <p:cNvPr id="3" name="TextBox 2"/>
-          <p:cNvSpPr txBox="1"/>
+              <a:rPr sz="3000" b="1" i="0">
+                <a:solidFill>
+                  <a:srgbClr val="1F2937"/>
+                </a:solidFill>
+                <a:latin typeface="Calibri Light"/>
+              </a:rPr>
+              <a:t>Three Ways a Grounded Answer Goes Wrong</a:t>
+            </a:r>
+          </a:p>
+        </p:txBody>
+      </p:sp>
+      <p:sp>
+        <p:nvSpPr>
+          <p:cNvPr id="3" name="Rectangle 2"/>
+          <p:cNvSpPr/>
           <p:nvPr/>
         </p:nvSpPr>
         <p:spPr>
           <a:xfrm>
-            <a:off x="777240" y="960120"/>
-            <a:ext cx="10637215" cy="731520"/>
+            <a:off x="777240" y="1417320"/>
+            <a:ext cx="1051560" cy="38100"/>
           </a:xfrm>
           <a:prstGeom prst="rect">
             <a:avLst/>
           </a:prstGeom>
-          <a:noFill/>
-        </p:spPr>
-        <p:txBody>
-          <a:bodyPr wrap="square" lIns="0" rIns="0" tIns="0" bIns="0">
-            <a:spAutoFit/>
-          </a:bodyPr>
-          <a:lstStyle/>
-          <a:p>
-            <a:r>
-              <a:rPr sz="3000" b="1" i="0">
-                <a:solidFill>
-                  <a:srgbClr val="1F2937"/>
-                </a:solidFill>
-                <a:latin typeface="Calibri Light"/>
-              </a:rPr>
-              <a:t>Build Your Grounded Assistant</a:t>
-            </a:r>
-          </a:p>
-        </p:txBody>
-      </p:sp>
-      <p:sp>
-        <p:nvSpPr>
-          <p:cNvPr id="4" name="Rectangle 3"/>
-          <p:cNvSpPr/>
-          <p:nvPr/>
-        </p:nvSpPr>
-        <p:spPr>
-          <a:xfrm>
-            <a:off x="777240" y="1783080"/>
-            <a:ext cx="1051560" cy="38100"/>
-          </a:xfrm>
-          <a:prstGeom prst="rect">
-            <a:avLst/>
-          </a:prstGeom>
           <a:solidFill>
-            <a:srgbClr val="B45309"/>
+            <a:srgbClr val="0F766E"/>
           </a:solidFill>
           <a:ln>
             <a:noFill/>
@@ -7906,14 +8046,542 @@
       </p:sp>
       <p:sp>
         <p:nvSpPr>
-          <p:cNvPr id="5" name="TextBox 4"/>
+          <p:cNvPr id="4" name="Rounded Rectangle 3"/>
+          <p:cNvSpPr/>
+          <p:nvPr/>
+        </p:nvSpPr>
+        <p:spPr>
+          <a:xfrm>
+            <a:off x="777240" y="2057400"/>
+            <a:ext cx="3301898" cy="3200400"/>
+          </a:xfrm>
+          <a:prstGeom prst="roundRect">
+            <a:avLst>
+              <a:gd name="adj" fmla="val 10000"/>
+            </a:avLst>
+          </a:prstGeom>
+          <a:solidFill>
+            <a:srgbClr val="F1F5F9"/>
+          </a:solidFill>
+          <a:ln w="15875">
+            <a:solidFill>
+              <a:srgbClr val="D3DDE6"/>
+            </a:solidFill>
+          </a:ln>
+          <a:effectLst/>
+        </p:spPr>
+        <p:style>
+          <a:lnRef idx="1">
+            <a:schemeClr val="accent1"/>
+          </a:lnRef>
+          <a:fillRef idx="3">
+            <a:schemeClr val="accent1"/>
+          </a:fillRef>
+          <a:effectRef idx="2">
+            <a:schemeClr val="accent1"/>
+          </a:effectRef>
+          <a:fontRef idx="minor">
+            <a:schemeClr val="lt1"/>
+          </a:fontRef>
+        </p:style>
+        <p:txBody>
+          <a:bodyPr rtlCol="0" anchor="ctr"/>
+          <a:lstStyle/>
+          <a:p>
+            <a:pPr algn="ctr"/>
+          </a:p>
+        </p:txBody>
+      </p:sp>
+      <p:sp>
+        <p:nvSpPr>
+          <p:cNvPr id="5" name="Rectangle 4"/>
+          <p:cNvSpPr/>
+          <p:nvPr/>
+        </p:nvSpPr>
+        <p:spPr>
+          <a:xfrm>
+            <a:off x="978408" y="2331720"/>
+            <a:ext cx="640080" cy="38100"/>
+          </a:xfrm>
+          <a:prstGeom prst="rect">
+            <a:avLst/>
+          </a:prstGeom>
+          <a:solidFill>
+            <a:srgbClr val="0F766E"/>
+          </a:solidFill>
+          <a:ln>
+            <a:noFill/>
+          </a:ln>
+          <a:effectLst/>
+        </p:spPr>
+        <p:style>
+          <a:lnRef idx="1">
+            <a:schemeClr val="accent1"/>
+          </a:lnRef>
+          <a:fillRef idx="3">
+            <a:schemeClr val="accent1"/>
+          </a:fillRef>
+          <a:effectRef idx="2">
+            <a:schemeClr val="accent1"/>
+          </a:effectRef>
+          <a:fontRef idx="minor">
+            <a:schemeClr val="lt1"/>
+          </a:fontRef>
+        </p:style>
+        <p:txBody>
+          <a:bodyPr rtlCol="0" anchor="ctr"/>
+          <a:lstStyle/>
+          <a:p>
+            <a:pPr algn="ctr"/>
+          </a:p>
+        </p:txBody>
+      </p:sp>
+      <p:sp>
+        <p:nvSpPr>
+          <p:cNvPr id="6" name="TextBox 5"/>
           <p:cNvSpPr txBox="1"/>
           <p:nvPr/>
         </p:nvSpPr>
         <p:spPr>
           <a:xfrm>
-            <a:off x="777240" y="2148840"/>
-            <a:ext cx="10637215" cy="3931920"/>
+            <a:off x="978408" y="2560320"/>
+            <a:ext cx="2899562" cy="640080"/>
+          </a:xfrm>
+          <a:prstGeom prst="rect">
+            <a:avLst/>
+          </a:prstGeom>
+          <a:noFill/>
+        </p:spPr>
+        <p:txBody>
+          <a:bodyPr wrap="square" lIns="0" rIns="0" tIns="0" bIns="0" anchor="t">
+            <a:spAutoFit/>
+          </a:bodyPr>
+          <a:lstStyle/>
+          <a:p>
+            <a:pPr algn="l">
+              <a:lnSpc>
+                <a:spcPct val="105000"/>
+              </a:lnSpc>
+              <a:spcAft>
+                <a:spcPts val="200"/>
+              </a:spcAft>
+            </a:pPr>
+            <a:r>
+              <a:rPr sz="1800" b="1" i="0">
+                <a:solidFill>
+                  <a:srgbClr val="1F2937"/>
+                </a:solidFill>
+                <a:latin typeface="Calibri"/>
+              </a:rPr>
+              <a:t>Answered from memory</a:t>
+            </a:r>
+          </a:p>
+        </p:txBody>
+      </p:sp>
+      <p:sp>
+        <p:nvSpPr>
+          <p:cNvPr id="7" name="TextBox 6"/>
+          <p:cNvSpPr txBox="1"/>
+          <p:nvPr/>
+        </p:nvSpPr>
+        <p:spPr>
+          <a:xfrm>
+            <a:off x="978408" y="3246120"/>
+            <a:ext cx="2899562" cy="1737360"/>
+          </a:xfrm>
+          <a:prstGeom prst="rect">
+            <a:avLst/>
+          </a:prstGeom>
+          <a:noFill/>
+        </p:spPr>
+        <p:txBody>
+          <a:bodyPr wrap="square" lIns="0" rIns="0" tIns="0" bIns="0" anchor="t">
+            <a:spAutoFit/>
+          </a:bodyPr>
+          <a:lstStyle/>
+          <a:p>
+            <a:pPr algn="l">
+              <a:lnSpc>
+                <a:spcPct val="105000"/>
+              </a:lnSpc>
+              <a:spcAft>
+                <a:spcPts val="200"/>
+              </a:spcAft>
+            </a:pPr>
+            <a:r>
+              <a:rPr sz="1350" b="0" i="0">
+                <a:solidFill>
+                  <a:srgbClr val="333D4B"/>
+                </a:solidFill>
+                <a:latin typeface="Calibri"/>
+              </a:rPr>
+              <a:t>Your documents did not contain it. The model knew something adjacent and used that instead. Detect it: the answer has no quotation, or a vague one.</a:t>
+            </a:r>
+          </a:p>
+        </p:txBody>
+      </p:sp>
+      <p:sp>
+        <p:nvSpPr>
+          <p:cNvPr id="8" name="Rounded Rectangle 7"/>
+          <p:cNvSpPr/>
+          <p:nvPr/>
+        </p:nvSpPr>
+        <p:spPr>
+          <a:xfrm>
+            <a:off x="4444898" y="2057400"/>
+            <a:ext cx="3301898" cy="3200400"/>
+          </a:xfrm>
+          <a:prstGeom prst="roundRect">
+            <a:avLst>
+              <a:gd name="adj" fmla="val 10000"/>
+            </a:avLst>
+          </a:prstGeom>
+          <a:solidFill>
+            <a:srgbClr val="F1F5F9"/>
+          </a:solidFill>
+          <a:ln w="15875">
+            <a:solidFill>
+              <a:srgbClr val="D3DDE6"/>
+            </a:solidFill>
+          </a:ln>
+          <a:effectLst/>
+        </p:spPr>
+        <p:style>
+          <a:lnRef idx="1">
+            <a:schemeClr val="accent1"/>
+          </a:lnRef>
+          <a:fillRef idx="3">
+            <a:schemeClr val="accent1"/>
+          </a:fillRef>
+          <a:effectRef idx="2">
+            <a:schemeClr val="accent1"/>
+          </a:effectRef>
+          <a:fontRef idx="minor">
+            <a:schemeClr val="lt1"/>
+          </a:fontRef>
+        </p:style>
+        <p:txBody>
+          <a:bodyPr rtlCol="0" anchor="ctr"/>
+          <a:lstStyle/>
+          <a:p>
+            <a:pPr algn="ctr"/>
+          </a:p>
+        </p:txBody>
+      </p:sp>
+      <p:sp>
+        <p:nvSpPr>
+          <p:cNvPr id="9" name="Rectangle 8"/>
+          <p:cNvSpPr/>
+          <p:nvPr/>
+        </p:nvSpPr>
+        <p:spPr>
+          <a:xfrm>
+            <a:off x="4646066" y="2331720"/>
+            <a:ext cx="640080" cy="38100"/>
+          </a:xfrm>
+          <a:prstGeom prst="rect">
+            <a:avLst/>
+          </a:prstGeom>
+          <a:solidFill>
+            <a:srgbClr val="0F766E"/>
+          </a:solidFill>
+          <a:ln>
+            <a:noFill/>
+          </a:ln>
+          <a:effectLst/>
+        </p:spPr>
+        <p:style>
+          <a:lnRef idx="1">
+            <a:schemeClr val="accent1"/>
+          </a:lnRef>
+          <a:fillRef idx="3">
+            <a:schemeClr val="accent1"/>
+          </a:fillRef>
+          <a:effectRef idx="2">
+            <a:schemeClr val="accent1"/>
+          </a:effectRef>
+          <a:fontRef idx="minor">
+            <a:schemeClr val="lt1"/>
+          </a:fontRef>
+        </p:style>
+        <p:txBody>
+          <a:bodyPr rtlCol="0" anchor="ctr"/>
+          <a:lstStyle/>
+          <a:p>
+            <a:pPr algn="ctr"/>
+          </a:p>
+        </p:txBody>
+      </p:sp>
+      <p:sp>
+        <p:nvSpPr>
+          <p:cNvPr id="10" name="TextBox 9"/>
+          <p:cNvSpPr txBox="1"/>
+          <p:nvPr/>
+        </p:nvSpPr>
+        <p:spPr>
+          <a:xfrm>
+            <a:off x="4646066" y="2560320"/>
+            <a:ext cx="2899562" cy="640080"/>
+          </a:xfrm>
+          <a:prstGeom prst="rect">
+            <a:avLst/>
+          </a:prstGeom>
+          <a:noFill/>
+        </p:spPr>
+        <p:txBody>
+          <a:bodyPr wrap="square" lIns="0" rIns="0" tIns="0" bIns="0" anchor="t">
+            <a:spAutoFit/>
+          </a:bodyPr>
+          <a:lstStyle/>
+          <a:p>
+            <a:pPr algn="l">
+              <a:lnSpc>
+                <a:spcPct val="105000"/>
+              </a:lnSpc>
+              <a:spcAft>
+                <a:spcPts val="200"/>
+              </a:spcAft>
+            </a:pPr>
+            <a:r>
+              <a:rPr sz="1800" b="1" i="0">
+                <a:solidFill>
+                  <a:srgbClr val="1F2937"/>
+                </a:solidFill>
+                <a:latin typeface="Calibri"/>
+              </a:rPr>
+              <a:t>Retrieved the wrong passage</a:t>
+            </a:r>
+          </a:p>
+        </p:txBody>
+      </p:sp>
+      <p:sp>
+        <p:nvSpPr>
+          <p:cNvPr id="11" name="TextBox 10"/>
+          <p:cNvSpPr txBox="1"/>
+          <p:nvPr/>
+        </p:nvSpPr>
+        <p:spPr>
+          <a:xfrm>
+            <a:off x="4646066" y="3246120"/>
+            <a:ext cx="2899562" cy="1737360"/>
+          </a:xfrm>
+          <a:prstGeom prst="rect">
+            <a:avLst/>
+          </a:prstGeom>
+          <a:noFill/>
+        </p:spPr>
+        <p:txBody>
+          <a:bodyPr wrap="square" lIns="0" rIns="0" tIns="0" bIns="0" anchor="t">
+            <a:spAutoFit/>
+          </a:bodyPr>
+          <a:lstStyle/>
+          <a:p>
+            <a:pPr algn="l">
+              <a:lnSpc>
+                <a:spcPct val="105000"/>
+              </a:lnSpc>
+              <a:spcAft>
+                <a:spcPts val="200"/>
+              </a:spcAft>
+            </a:pPr>
+            <a:r>
+              <a:rPr sz="1350" b="0" i="0">
+                <a:solidFill>
+                  <a:srgbClr val="333D4B"/>
+                </a:solidFill>
+                <a:latin typeface="Calibri"/>
+              </a:rPr>
+              <a:t>The right words appeared somewhere unrelated. The quotation is genuine and the conclusion is wrong. Detect it: read the quoted passage in its original context.</a:t>
+            </a:r>
+          </a:p>
+        </p:txBody>
+      </p:sp>
+      <p:sp>
+        <p:nvSpPr>
+          <p:cNvPr id="12" name="Rounded Rectangle 11"/>
+          <p:cNvSpPr/>
+          <p:nvPr/>
+        </p:nvSpPr>
+        <p:spPr>
+          <a:xfrm>
+            <a:off x="8112556" y="2057400"/>
+            <a:ext cx="3301898" cy="3200400"/>
+          </a:xfrm>
+          <a:prstGeom prst="roundRect">
+            <a:avLst>
+              <a:gd name="adj" fmla="val 10000"/>
+            </a:avLst>
+          </a:prstGeom>
+          <a:solidFill>
+            <a:srgbClr val="F1F5F9"/>
+          </a:solidFill>
+          <a:ln w="15875">
+            <a:solidFill>
+              <a:srgbClr val="D3DDE6"/>
+            </a:solidFill>
+          </a:ln>
+          <a:effectLst/>
+        </p:spPr>
+        <p:style>
+          <a:lnRef idx="1">
+            <a:schemeClr val="accent1"/>
+          </a:lnRef>
+          <a:fillRef idx="3">
+            <a:schemeClr val="accent1"/>
+          </a:fillRef>
+          <a:effectRef idx="2">
+            <a:schemeClr val="accent1"/>
+          </a:effectRef>
+          <a:fontRef idx="minor">
+            <a:schemeClr val="lt1"/>
+          </a:fontRef>
+        </p:style>
+        <p:txBody>
+          <a:bodyPr rtlCol="0" anchor="ctr"/>
+          <a:lstStyle/>
+          <a:p>
+            <a:pPr algn="ctr"/>
+          </a:p>
+        </p:txBody>
+      </p:sp>
+      <p:sp>
+        <p:nvSpPr>
+          <p:cNvPr id="13" name="Rectangle 12"/>
+          <p:cNvSpPr/>
+          <p:nvPr/>
+        </p:nvSpPr>
+        <p:spPr>
+          <a:xfrm>
+            <a:off x="8313724" y="2331720"/>
+            <a:ext cx="640080" cy="38100"/>
+          </a:xfrm>
+          <a:prstGeom prst="rect">
+            <a:avLst/>
+          </a:prstGeom>
+          <a:solidFill>
+            <a:srgbClr val="0F766E"/>
+          </a:solidFill>
+          <a:ln>
+            <a:noFill/>
+          </a:ln>
+          <a:effectLst/>
+        </p:spPr>
+        <p:style>
+          <a:lnRef idx="1">
+            <a:schemeClr val="accent1"/>
+          </a:lnRef>
+          <a:fillRef idx="3">
+            <a:schemeClr val="accent1"/>
+          </a:fillRef>
+          <a:effectRef idx="2">
+            <a:schemeClr val="accent1"/>
+          </a:effectRef>
+          <a:fontRef idx="minor">
+            <a:schemeClr val="lt1"/>
+          </a:fontRef>
+        </p:style>
+        <p:txBody>
+          <a:bodyPr rtlCol="0" anchor="ctr"/>
+          <a:lstStyle/>
+          <a:p>
+            <a:pPr algn="ctr"/>
+          </a:p>
+        </p:txBody>
+      </p:sp>
+      <p:sp>
+        <p:nvSpPr>
+          <p:cNvPr id="14" name="TextBox 13"/>
+          <p:cNvSpPr txBox="1"/>
+          <p:nvPr/>
+        </p:nvSpPr>
+        <p:spPr>
+          <a:xfrm>
+            <a:off x="8313724" y="2560320"/>
+            <a:ext cx="2899562" cy="640080"/>
+          </a:xfrm>
+          <a:prstGeom prst="rect">
+            <a:avLst/>
+          </a:prstGeom>
+          <a:noFill/>
+        </p:spPr>
+        <p:txBody>
+          <a:bodyPr wrap="square" lIns="0" rIns="0" tIns="0" bIns="0" anchor="t">
+            <a:spAutoFit/>
+          </a:bodyPr>
+          <a:lstStyle/>
+          <a:p>
+            <a:pPr algn="l">
+              <a:lnSpc>
+                <a:spcPct val="105000"/>
+              </a:lnSpc>
+              <a:spcAft>
+                <a:spcPts val="200"/>
+              </a:spcAft>
+            </a:pPr>
+            <a:r>
+              <a:rPr sz="1800" b="1" i="0">
+                <a:solidFill>
+                  <a:srgbClr val="1F2937"/>
+                </a:solidFill>
+                <a:latin typeface="Calibri"/>
+              </a:rPr>
+              <a:t>Over-read the passage</a:t>
+            </a:r>
+          </a:p>
+        </p:txBody>
+      </p:sp>
+      <p:sp>
+        <p:nvSpPr>
+          <p:cNvPr id="15" name="TextBox 14"/>
+          <p:cNvSpPr txBox="1"/>
+          <p:nvPr/>
+        </p:nvSpPr>
+        <p:spPr>
+          <a:xfrm>
+            <a:off x="8313724" y="3246120"/>
+            <a:ext cx="2899562" cy="1737360"/>
+          </a:xfrm>
+          <a:prstGeom prst="rect">
+            <a:avLst/>
+          </a:prstGeom>
+          <a:noFill/>
+        </p:spPr>
+        <p:txBody>
+          <a:bodyPr wrap="square" lIns="0" rIns="0" tIns="0" bIns="0" anchor="t">
+            <a:spAutoFit/>
+          </a:bodyPr>
+          <a:lstStyle/>
+          <a:p>
+            <a:pPr algn="l">
+              <a:lnSpc>
+                <a:spcPct val="105000"/>
+              </a:lnSpc>
+              <a:spcAft>
+                <a:spcPts val="200"/>
+              </a:spcAft>
+            </a:pPr>
+            <a:r>
+              <a:rPr sz="1350" b="0" i="0">
+                <a:solidFill>
+                  <a:srgbClr val="333D4B"/>
+                </a:solidFill>
+                <a:latin typeface="Calibri"/>
+              </a:rPr>
+              <a:t>The source says something narrower than the answer claims. "May" becomes "must". An example becomes a rule. Detect it: compare the strength of the claim with the strength of the quote.</a:t>
+            </a:r>
+          </a:p>
+        </p:txBody>
+      </p:sp>
+      <p:sp>
+        <p:nvSpPr>
+          <p:cNvPr id="16" name="TextBox 15"/>
+          <p:cNvSpPr txBox="1"/>
+          <p:nvPr/>
+        </p:nvSpPr>
+        <p:spPr>
+          <a:xfrm>
+            <a:off x="777240" y="6355080"/>
+            <a:ext cx="10637215" cy="274320"/>
           </a:xfrm>
           <a:prstGeom prst="rect">
             <a:avLst/>
@@ -7926,162 +8594,6 @@
           </a:bodyPr>
           <a:lstStyle/>
           <a:p>
-            <a:pPr>
-              <a:lnSpc>
-                <a:spcPct val="115000"/>
-              </a:lnSpc>
-              <a:spcAft>
-                <a:spcPts val="1000"/>
-              </a:spcAft>
-            </a:pPr>
-            <a:r>
-              <a:rPr sz="1900" b="1" i="0">
-                <a:solidFill>
-                  <a:srgbClr val="1F2937"/>
-                </a:solidFill>
-                <a:latin typeface="Calibri"/>
-              </a:rPr>
-              <a:t>•  1.  Choose your sources — three to five short documents.</a:t>
-            </a:r>
-          </a:p>
-          <a:p>
-            <a:pPr lvl="1">
-              <a:lnSpc>
-                <a:spcPct val="115000"/>
-              </a:lnSpc>
-              <a:spcAft>
-                <a:spcPts val="500"/>
-              </a:spcAft>
-            </a:pPr>
-            <a:r>
-              <a:rPr sz="1600" b="0" i="0">
-                <a:solidFill>
-                  <a:srgbClr val="333D4B"/>
-                </a:solidFill>
-                <a:latin typeface="Calibri"/>
-              </a:rPr>
-              <a:t>—  Bring your own, or take a pack from me: clinical guideline, statute extract, course regulations, annual report, technical standard.</a:t>
-            </a:r>
-          </a:p>
-          <a:p>
-            <a:pPr>
-              <a:lnSpc>
-                <a:spcPct val="115000"/>
-              </a:lnSpc>
-              <a:spcAft>
-                <a:spcPts val="1000"/>
-              </a:spcAft>
-            </a:pPr>
-            <a:r>
-              <a:rPr sz="1900" b="1" i="0">
-                <a:solidFill>
-                  <a:srgbClr val="1F2937"/>
-                </a:solidFill>
-                <a:latin typeface="Calibri"/>
-              </a:rPr>
-              <a:t>•  2.  Load them into any tool that lets you attach documents and ask questions about them.</a:t>
-            </a:r>
-          </a:p>
-          <a:p>
-            <a:pPr lvl="1">
-              <a:lnSpc>
-                <a:spcPct val="115000"/>
-              </a:lnSpc>
-              <a:spcAft>
-                <a:spcPts val="500"/>
-              </a:spcAft>
-            </a:pPr>
-            <a:r>
-              <a:rPr sz="1600" b="0" i="0">
-                <a:solidFill>
-                  <a:srgbClr val="333D4B"/>
-                </a:solidFill>
-                <a:latin typeface="Calibri"/>
-              </a:rPr>
-              <a:t>—  Several free assistants do this. Notebook-style tools do it well. Any of them is fine.</a:t>
-            </a:r>
-          </a:p>
-          <a:p>
-            <a:pPr>
-              <a:lnSpc>
-                <a:spcPct val="115000"/>
-              </a:lnSpc>
-              <a:spcAft>
-                <a:spcPts val="1000"/>
-              </a:spcAft>
-            </a:pPr>
-            <a:r>
-              <a:rPr sz="1900" b="1" i="0">
-                <a:solidFill>
-                  <a:srgbClr val="1F2937"/>
-                </a:solidFill>
-                <a:latin typeface="Calibri"/>
-              </a:rPr>
-              <a:t>•  3.  Add the three instructions.</a:t>
-            </a:r>
-          </a:p>
-          <a:p>
-            <a:pPr lvl="1">
-              <a:lnSpc>
-                <a:spcPct val="115000"/>
-              </a:lnSpc>
-              <a:spcAft>
-                <a:spcPts val="500"/>
-              </a:spcAft>
-            </a:pPr>
-            <a:r>
-              <a:rPr sz="1600" b="0" i="0">
-                <a:solidFill>
-                  <a:srgbClr val="333D4B"/>
-                </a:solidFill>
-                <a:latin typeface="Calibri"/>
-              </a:rPr>
-              <a:t>—  Answer only from the documents · quote the supporting sentence · reply NOT IN SOURCES if absent.</a:t>
-            </a:r>
-          </a:p>
-          <a:p>
-            <a:pPr>
-              <a:lnSpc>
-                <a:spcPct val="115000"/>
-              </a:lnSpc>
-              <a:spcAft>
-                <a:spcPts val="1000"/>
-              </a:spcAft>
-            </a:pPr>
-            <a:r>
-              <a:rPr sz="1900" b="1" i="0">
-                <a:solidFill>
-                  <a:srgbClr val="1F2937"/>
-                </a:solidFill>
-                <a:latin typeface="Calibri"/>
-              </a:rPr>
-              <a:t>•  4.  Ask five questions. Check every quotation against the source.</a:t>
-            </a:r>
-          </a:p>
-        </p:txBody>
-      </p:sp>
-      <p:sp>
-        <p:nvSpPr>
-          <p:cNvPr id="6" name="TextBox 5"/>
-          <p:cNvSpPr txBox="1"/>
-          <p:nvPr/>
-        </p:nvSpPr>
-        <p:spPr>
-          <a:xfrm>
-            <a:off x="777240" y="6355080"/>
-            <a:ext cx="10637215" cy="274320"/>
-          </a:xfrm>
-          <a:prstGeom prst="rect">
-            <a:avLst/>
-          </a:prstGeom>
-          <a:noFill/>
-        </p:spPr>
-        <p:txBody>
-          <a:bodyPr wrap="square" lIns="0" rIns="0" tIns="0" bIns="0">
-            <a:spAutoFit/>
-          </a:bodyPr>
-          <a:lstStyle/>
-          <a:p>
             <a:r>
               <a:rPr sz="1000" b="0" i="0">
                 <a:solidFill>
@@ -8096,7 +8608,7 @@
       </p:sp>
       <p:sp>
         <p:nvSpPr>
-          <p:cNvPr id="7" name="TextBox 6"/>
+          <p:cNvPr id="17" name="TextBox 16"/>
           <p:cNvSpPr txBox="1"/>
           <p:nvPr/>
         </p:nvSpPr>
@@ -8149,48 +8661,14 @@
       <p:grpSpPr/>
       <p:sp>
         <p:nvSpPr>
-          <p:cNvPr id="2" name="TextBox 1"/>
-          <p:cNvSpPr txBox="1"/>
-          <p:nvPr/>
-        </p:nvSpPr>
-        <p:spPr>
-          <a:xfrm>
-            <a:off x="777240" y="566928"/>
-            <a:ext cx="10637215" cy="822960"/>
-          </a:xfrm>
-          <a:prstGeom prst="rect">
-            <a:avLst/>
-          </a:prstGeom>
-          <a:noFill/>
-        </p:spPr>
-        <p:txBody>
-          <a:bodyPr wrap="square" lIns="0" rIns="0" tIns="0" bIns="0">
-            <a:spAutoFit/>
-          </a:bodyPr>
-          <a:lstStyle/>
-          <a:p>
-            <a:r>
-              <a:rPr sz="3000" b="1" i="0">
-                <a:solidFill>
-                  <a:srgbClr val="1F2937"/>
-                </a:solidFill>
-                <a:latin typeface="Calibri Light"/>
-              </a:rPr>
-              <a:t>What You Probably Found</a:t>
-            </a:r>
-          </a:p>
-        </p:txBody>
-      </p:sp>
-      <p:sp>
-        <p:nvSpPr>
-          <p:cNvPr id="3" name="Rectangle 2"/>
+          <p:cNvPr id="2" name="Rectangle 1"/>
           <p:cNvSpPr/>
           <p:nvPr/>
         </p:nvSpPr>
         <p:spPr>
           <a:xfrm>
-            <a:off x="777240" y="1417320"/>
-            <a:ext cx="1051560" cy="38100"/>
+            <a:off x="0" y="0"/>
+            <a:ext cx="292608" cy="6858000"/>
           </a:xfrm>
           <a:prstGeom prst="rect">
             <a:avLst/>
@@ -8227,14 +8705,48 @@
       </p:sp>
       <p:sp>
         <p:nvSpPr>
+          <p:cNvPr id="3" name="TextBox 2"/>
+          <p:cNvSpPr txBox="1"/>
+          <p:nvPr/>
+        </p:nvSpPr>
+        <p:spPr>
+          <a:xfrm>
+            <a:off x="1280160" y="2743200"/>
+            <a:ext cx="10058400" cy="457200"/>
+          </a:xfrm>
+          <a:prstGeom prst="rect">
+            <a:avLst/>
+          </a:prstGeom>
+          <a:noFill/>
+        </p:spPr>
+        <p:txBody>
+          <a:bodyPr wrap="square" lIns="0" rIns="0" tIns="0" bIns="0">
+            <a:spAutoFit/>
+          </a:bodyPr>
+          <a:lstStyle/>
+          <a:p>
+            <a:r>
+              <a:rPr sz="1400" b="1" i="0">
+                <a:solidFill>
+                  <a:srgbClr val="0F766E"/>
+                </a:solidFill>
+                <a:latin typeface="Calibri"/>
+              </a:rPr>
+              <a:t>PART 4</a:t>
+            </a:r>
+          </a:p>
+        </p:txBody>
+      </p:sp>
+      <p:sp>
+        <p:nvSpPr>
           <p:cNvPr id="4" name="TextBox 3"/>
           <p:cNvSpPr txBox="1"/>
           <p:nvPr/>
         </p:nvSpPr>
         <p:spPr>
           <a:xfrm>
-            <a:off x="777240" y="1783080"/>
-            <a:ext cx="10637215" cy="4343400"/>
+            <a:off x="1280160" y="3200400"/>
+            <a:ext cx="10058400" cy="1097280"/>
           </a:xfrm>
           <a:prstGeom prst="rect">
             <a:avLst/>
@@ -8247,196 +8759,14 @@
           </a:bodyPr>
           <a:lstStyle/>
           <a:p>
-            <a:pPr lvl="1">
-              <a:lnSpc>
-                <a:spcPct val="115000"/>
-              </a:lnSpc>
-              <a:spcAft>
-                <a:spcPts val="500"/>
-              </a:spcAft>
-            </a:pPr>
-            <a:r>
-              <a:rPr sz="1600" b="0" i="0">
-                <a:solidFill>
-                  <a:srgbClr val="333D4B"/>
-                </a:solidFill>
-                <a:latin typeface="Calibri"/>
-              </a:rPr>
-              <a:t>—  With the three instructions, it refused at least once — and the refusal was correct</a:t>
-            </a:r>
-          </a:p>
-          <a:p>
-            <a:pPr lvl="1">
-              <a:lnSpc>
-                <a:spcPct val="115000"/>
-              </a:lnSpc>
-              <a:spcAft>
-                <a:spcPts val="500"/>
-              </a:spcAft>
-            </a:pPr>
-            <a:r>
-              <a:rPr sz="1600" b="0" i="0">
-                <a:solidFill>
-                  <a:srgbClr val="333D4B"/>
-                </a:solidFill>
-                <a:latin typeface="Calibri"/>
-              </a:rPr>
-              <a:t>—  Quotations were usually genuine. "Usually" is the operative word.</a:t>
-            </a:r>
-          </a:p>
-          <a:p>
-            <a:pPr lvl="1">
-              <a:lnSpc>
-                <a:spcPct val="115000"/>
-              </a:lnSpc>
-              <a:spcAft>
-                <a:spcPts val="500"/>
-              </a:spcAft>
-            </a:pPr>
-            <a:r>
-              <a:rPr sz="1600" b="0" i="0">
-                <a:solidFill>
-                  <a:srgbClr val="333D4B"/>
-                </a:solidFill>
-                <a:latin typeface="Calibri"/>
-              </a:rPr>
-              <a:t>—  At least one answer was broader than the sentence it quoted</a:t>
-            </a:r>
-          </a:p>
-          <a:p>
-            <a:pPr lvl="1">
-              <a:lnSpc>
-                <a:spcPct val="115000"/>
-              </a:lnSpc>
-              <a:spcAft>
-                <a:spcPts val="500"/>
-              </a:spcAft>
-            </a:pPr>
-            <a:r>
-              <a:rPr sz="1600" b="0" i="0">
-                <a:solidFill>
-                  <a:srgbClr val="333D4B"/>
-                </a:solidFill>
-                <a:latin typeface="Calibri"/>
-              </a:rPr>
-              <a:t>—  Questions spanning several documents were answered worse than questions inside one document</a:t>
-            </a:r>
-          </a:p>
-          <a:p>
-            <a:pPr>
-              <a:lnSpc>
-                <a:spcPct val="115000"/>
-              </a:lnSpc>
-              <a:spcAft>
-                <a:spcPts val="1000"/>
-              </a:spcAft>
-            </a:pPr>
-          </a:p>
-          <a:p>
-            <a:pPr>
-              <a:lnSpc>
-                <a:spcPct val="115000"/>
-              </a:lnSpc>
-              <a:spcAft>
-                <a:spcPts val="1000"/>
-              </a:spcAft>
-            </a:pPr>
-            <a:r>
-              <a:rPr sz="1900" b="1" i="0">
+            <a:r>
+              <a:rPr sz="3400" b="1" i="0">
                 <a:solidFill>
                   <a:srgbClr val="1F2937"/>
                 </a:solidFill>
-                <a:latin typeface="Calibri"/>
-              </a:rPr>
-              <a:t>•  The last one is structural and worth remembering:</a:t>
-            </a:r>
-          </a:p>
-          <a:p>
-            <a:pPr lvl="1">
-              <a:lnSpc>
-                <a:spcPct val="115000"/>
-              </a:lnSpc>
-              <a:spcAft>
-                <a:spcPts val="500"/>
-              </a:spcAft>
-            </a:pPr>
-            <a:r>
-              <a:rPr sz="1600" b="0" i="0">
-                <a:solidFill>
-                  <a:srgbClr val="333D4B"/>
-                </a:solidFill>
-                <a:latin typeface="Calibri"/>
-              </a:rPr>
-              <a:t>—  Retrieval pulls passages, not whole documents. Anything requiring you to combine three separate places is fragile.</a:t>
-            </a:r>
-          </a:p>
-        </p:txBody>
-      </p:sp>
-      <p:sp>
-        <p:nvSpPr>
-          <p:cNvPr id="5" name="TextBox 4"/>
-          <p:cNvSpPr txBox="1"/>
-          <p:nvPr/>
-        </p:nvSpPr>
-        <p:spPr>
-          <a:xfrm>
-            <a:off x="777240" y="6355080"/>
-            <a:ext cx="10637215" cy="274320"/>
-          </a:xfrm>
-          <a:prstGeom prst="rect">
-            <a:avLst/>
-          </a:prstGeom>
-          <a:noFill/>
-        </p:spPr>
-        <p:txBody>
-          <a:bodyPr wrap="square" lIns="0" rIns="0" tIns="0" bIns="0">
-            <a:spAutoFit/>
-          </a:bodyPr>
-          <a:lstStyle/>
-          <a:p>
-            <a:r>
-              <a:rPr sz="1000" b="0" i="0">
-                <a:solidFill>
-                  <a:srgbClr val="6B7787"/>
-                </a:solidFill>
-                <a:latin typeface="Calibri"/>
-              </a:rPr>
-              <a:t>Week 7  ·  Prompt Engineering and Large Language Models</a:t>
-            </a:r>
-          </a:p>
-        </p:txBody>
-      </p:sp>
-      <p:sp>
-        <p:nvSpPr>
-          <p:cNvPr id="6" name="TextBox 5"/>
-          <p:cNvSpPr txBox="1"/>
-          <p:nvPr/>
-        </p:nvSpPr>
-        <p:spPr>
-          <a:xfrm>
-            <a:off x="10500055" y="6355080"/>
-            <a:ext cx="914400" cy="274320"/>
-          </a:xfrm>
-          <a:prstGeom prst="rect">
-            <a:avLst/>
-          </a:prstGeom>
-          <a:noFill/>
-        </p:spPr>
-        <p:txBody>
-          <a:bodyPr wrap="square" lIns="0" rIns="0" tIns="0" bIns="0">
-            <a:spAutoFit/>
-          </a:bodyPr>
-          <a:lstStyle/>
-          <a:p>
-            <a:pPr algn="r"/>
-            <a:r>
-              <a:rPr sz="1000" b="0" i="0">
-                <a:solidFill>
-                  <a:srgbClr val="6B7787"/>
-                </a:solidFill>
-                <a:latin typeface="Calibri"/>
-              </a:rPr>
-              <a:t>16</a:t>
+                <a:latin typeface="Calibri Light"/>
+              </a:rPr>
+              <a:t>Build</a:t>
             </a:r>
           </a:p>
         </p:txBody>
@@ -8468,7 +8798,7 @@
         <p:spPr>
           <a:xfrm>
             <a:off x="777240" y="566928"/>
-            <a:ext cx="10637215" cy="822960"/>
+            <a:ext cx="10637215" cy="365760"/>
           </a:xfrm>
           <a:prstGeom prst="rect">
             <a:avLst/>
@@ -8482,33 +8812,67 @@
           <a:lstStyle/>
           <a:p>
             <a:r>
+              <a:rPr sz="1300" b="1" i="0">
+                <a:solidFill>
+                  <a:srgbClr val="B45309"/>
+                </a:solidFill>
+                <a:latin typeface="Calibri"/>
+              </a:rPr>
+              <a:t>IN-CLASS ACTIVITY  ·  20 MINUTES</a:t>
+            </a:r>
+          </a:p>
+        </p:txBody>
+      </p:sp>
+      <p:sp>
+        <p:nvSpPr>
+          <p:cNvPr id="3" name="TextBox 2"/>
+          <p:cNvSpPr txBox="1"/>
+          <p:nvPr/>
+        </p:nvSpPr>
+        <p:spPr>
+          <a:xfrm>
+            <a:off x="777240" y="960120"/>
+            <a:ext cx="10637215" cy="731520"/>
+          </a:xfrm>
+          <a:prstGeom prst="rect">
+            <a:avLst/>
+          </a:prstGeom>
+          <a:noFill/>
+        </p:spPr>
+        <p:txBody>
+          <a:bodyPr wrap="square" lIns="0" rIns="0" tIns="0" bIns="0">
+            <a:spAutoFit/>
+          </a:bodyPr>
+          <a:lstStyle/>
+          <a:p>
+            <a:r>
               <a:rPr sz="3000" b="1" i="0">
                 <a:solidFill>
                   <a:srgbClr val="1F2937"/>
                 </a:solidFill>
                 <a:latin typeface="Calibri Light"/>
               </a:rPr>
-              <a:t>Concepts You Must Be Able to Define and Diagnose</a:t>
-            </a:r>
-          </a:p>
-        </p:txBody>
-      </p:sp>
-      <p:sp>
-        <p:nvSpPr>
-          <p:cNvPr id="3" name="Rectangle 2"/>
+              <a:t>Build Your Grounded Assistant</a:t>
+            </a:r>
+          </a:p>
+        </p:txBody>
+      </p:sp>
+      <p:sp>
+        <p:nvSpPr>
+          <p:cNvPr id="4" name="Rectangle 3"/>
           <p:cNvSpPr/>
           <p:nvPr/>
         </p:nvSpPr>
         <p:spPr>
           <a:xfrm>
-            <a:off x="777240" y="1417320"/>
+            <a:off x="777240" y="1783080"/>
             <a:ext cx="1051560" cy="38100"/>
           </a:xfrm>
           <a:prstGeom prst="rect">
             <a:avLst/>
           </a:prstGeom>
           <a:solidFill>
-            <a:srgbClr val="0F766E"/>
+            <a:srgbClr val="B45309"/>
           </a:solidFill>
           <a:ln>
             <a:noFill/>
@@ -8539,58 +8903,14 @@
       </p:sp>
       <p:sp>
         <p:nvSpPr>
-          <p:cNvPr id="4" name="Rectangle 3"/>
-          <p:cNvSpPr/>
-          <p:nvPr/>
-        </p:nvSpPr>
-        <p:spPr>
-          <a:xfrm>
-            <a:off x="777240" y="1783080"/>
-            <a:ext cx="10637215" cy="4251960"/>
-          </a:xfrm>
-          <a:prstGeom prst="rect">
-            <a:avLst/>
-          </a:prstGeom>
-          <a:solidFill>
-            <a:srgbClr val="F1F5F9"/>
-          </a:solidFill>
-          <a:ln>
-            <a:noFill/>
-          </a:ln>
-          <a:effectLst/>
-        </p:spPr>
-        <p:style>
-          <a:lnRef idx="1">
-            <a:schemeClr val="accent1"/>
-          </a:lnRef>
-          <a:fillRef idx="3">
-            <a:schemeClr val="accent1"/>
-          </a:fillRef>
-          <a:effectRef idx="2">
-            <a:schemeClr val="accent1"/>
-          </a:effectRef>
-          <a:fontRef idx="minor">
-            <a:schemeClr val="lt1"/>
-          </a:fontRef>
-        </p:style>
-        <p:txBody>
-          <a:bodyPr rtlCol="0" anchor="ctr"/>
-          <a:lstStyle/>
-          <a:p>
-            <a:pPr algn="ctr"/>
-          </a:p>
-        </p:txBody>
-      </p:sp>
-      <p:sp>
-        <p:nvSpPr>
           <p:cNvPr id="5" name="TextBox 4"/>
           <p:cNvSpPr txBox="1"/>
           <p:nvPr/>
         </p:nvSpPr>
         <p:spPr>
           <a:xfrm>
-            <a:off x="1188720" y="2103120"/>
-            <a:ext cx="9814255" cy="3611880"/>
+            <a:off x="777240" y="2148840"/>
+            <a:ext cx="10637215" cy="3931920"/>
           </a:xfrm>
           <a:prstGeom prst="rect">
             <a:avLst/>
@@ -8618,7 +8938,7 @@
                 </a:solidFill>
                 <a:latin typeface="Calibri"/>
               </a:rPr>
-              <a:t>•  Grounding</a:t>
+              <a:t>•  1.  Choose your sources — three to five short documents.</a:t>
             </a:r>
           </a:p>
           <a:p>
@@ -8637,7 +8957,7 @@
                 </a:solidFill>
                 <a:latin typeface="Calibri"/>
               </a:rPr>
-              <a:t>—  Placing relevant passages from chosen sources into the context so the model answers from them rather than from memory. Also called retrieval-augmented generation.</a:t>
+              <a:t>—  Bring your own, or take a pack from me: clinical guideline, statute extract, course regulations, annual report, technical standard.</a:t>
             </a:r>
           </a:p>
           <a:p>
@@ -8656,7 +8976,7 @@
                 </a:solidFill>
                 <a:latin typeface="Calibri"/>
               </a:rPr>
-              <a:t>•  What grounding does and does not do</a:t>
+              <a:t>•  2.  Load them into any tool that lets you attach documents and ask questions about them.</a:t>
             </a:r>
           </a:p>
           <a:p>
@@ -8675,7 +8995,7 @@
                 </a:solidFill>
                 <a:latin typeface="Calibri"/>
               </a:rPr>
-              <a:t>—  Changes where the answer comes from. Does not install a truth check, and does not fix a wrong source.</a:t>
+              <a:t>—  Several free assistants do this. Notebook-style tools do it well. Any of them is fine.</a:t>
             </a:r>
           </a:p>
           <a:p>
@@ -8694,7 +9014,7 @@
                 </a:solidFill>
                 <a:latin typeface="Calibri"/>
               </a:rPr>
-              <a:t>•  Why prompting cannot substitute</a:t>
+              <a:t>•  3.  Add the three instructions.</a:t>
             </a:r>
           </a:p>
           <a:p>
@@ -8713,7 +9033,7 @@
                 </a:solidFill>
                 <a:latin typeface="Calibri"/>
               </a:rPr>
-              <a:t>—  Instructions change tone and shape, never available information. "Be accurate" adds authority, not facts.</a:t>
+              <a:t>—  Answer only from the documents · quote the supporting sentence · reply NOT IN SOURCES if absent.</a:t>
             </a:r>
           </a:p>
           <a:p>
@@ -8732,64 +9052,7 @@
                 </a:solidFill>
                 <a:latin typeface="Calibri"/>
               </a:rPr>
-              <a:t>•  The three verification instructions</a:t>
-            </a:r>
-          </a:p>
-          <a:p>
-            <a:pPr lvl="1">
-              <a:lnSpc>
-                <a:spcPct val="115000"/>
-              </a:lnSpc>
-              <a:spcAft>
-                <a:spcPts val="500"/>
-              </a:spcAft>
-            </a:pPr>
-            <a:r>
-              <a:rPr sz="1600" b="0" i="0">
-                <a:solidFill>
-                  <a:srgbClr val="333D4B"/>
-                </a:solidFill>
-                <a:latin typeface="Calibri"/>
-              </a:rPr>
-              <a:t>—  Answer only from sources · quote the supporting sentence · a fixed, visible refusal string.</a:t>
-            </a:r>
-          </a:p>
-          <a:p>
-            <a:pPr>
-              <a:lnSpc>
-                <a:spcPct val="115000"/>
-              </a:lnSpc>
-              <a:spcAft>
-                <a:spcPts val="1000"/>
-              </a:spcAft>
-            </a:pPr>
-            <a:r>
-              <a:rPr sz="1900" b="1" i="0">
-                <a:solidFill>
-                  <a:srgbClr val="1F2937"/>
-                </a:solidFill>
-                <a:latin typeface="Calibri"/>
-              </a:rPr>
-              <a:t>•  Three grounded failure modes</a:t>
-            </a:r>
-          </a:p>
-          <a:p>
-            <a:pPr lvl="1">
-              <a:lnSpc>
-                <a:spcPct val="115000"/>
-              </a:lnSpc>
-              <a:spcAft>
-                <a:spcPts val="500"/>
-              </a:spcAft>
-            </a:pPr>
-            <a:r>
-              <a:rPr sz="1600" b="0" i="0">
-                <a:solidFill>
-                  <a:srgbClr val="333D4B"/>
-                </a:solidFill>
-                <a:latin typeface="Calibri"/>
-              </a:rPr>
-              <a:t>—  Answered from memory · retrieved the wrong passage · over-read the passage.</a:t>
+              <a:t>•  4.  Ask five questions. Check every quotation against the source.</a:t>
             </a:r>
           </a:p>
         </p:txBody>
@@ -8910,7 +9173,7 @@
                 </a:solidFill>
                 <a:latin typeface="Calibri Light"/>
               </a:rPr>
-              <a:t>Wrap-Up</a:t>
+              <a:t>What You Probably Found</a:t>
             </a:r>
           </a:p>
         </p:txBody>
@@ -8981,6 +9244,82 @@
           </a:bodyPr>
           <a:lstStyle/>
           <a:p>
+            <a:pPr lvl="1">
+              <a:lnSpc>
+                <a:spcPct val="115000"/>
+              </a:lnSpc>
+              <a:spcAft>
+                <a:spcPts val="500"/>
+              </a:spcAft>
+            </a:pPr>
+            <a:r>
+              <a:rPr sz="1600" b="0" i="0">
+                <a:solidFill>
+                  <a:srgbClr val="333D4B"/>
+                </a:solidFill>
+                <a:latin typeface="Calibri"/>
+              </a:rPr>
+              <a:t>—  With the three instructions, it refused at least once — and the refusal was correct</a:t>
+            </a:r>
+          </a:p>
+          <a:p>
+            <a:pPr lvl="1">
+              <a:lnSpc>
+                <a:spcPct val="115000"/>
+              </a:lnSpc>
+              <a:spcAft>
+                <a:spcPts val="500"/>
+              </a:spcAft>
+            </a:pPr>
+            <a:r>
+              <a:rPr sz="1600" b="0" i="0">
+                <a:solidFill>
+                  <a:srgbClr val="333D4B"/>
+                </a:solidFill>
+                <a:latin typeface="Calibri"/>
+              </a:rPr>
+              <a:t>—  Quotations were usually genuine. "Usually" is the operative word.</a:t>
+            </a:r>
+          </a:p>
+          <a:p>
+            <a:pPr lvl="1">
+              <a:lnSpc>
+                <a:spcPct val="115000"/>
+              </a:lnSpc>
+              <a:spcAft>
+                <a:spcPts val="500"/>
+              </a:spcAft>
+            </a:pPr>
+            <a:r>
+              <a:rPr sz="1600" b="0" i="0">
+                <a:solidFill>
+                  <a:srgbClr val="333D4B"/>
+                </a:solidFill>
+                <a:latin typeface="Calibri"/>
+              </a:rPr>
+              <a:t>—  At least one answer was broader than the sentence it quoted</a:t>
+            </a:r>
+          </a:p>
+          <a:p>
+            <a:pPr lvl="1">
+              <a:lnSpc>
+                <a:spcPct val="115000"/>
+              </a:lnSpc>
+              <a:spcAft>
+                <a:spcPts val="500"/>
+              </a:spcAft>
+            </a:pPr>
+            <a:r>
+              <a:rPr sz="1600" b="0" i="0">
+                <a:solidFill>
+                  <a:srgbClr val="333D4B"/>
+                </a:solidFill>
+                <a:latin typeface="Calibri"/>
+              </a:rPr>
+              <a:t>—  Questions spanning several documents were answered worse than questions inside one document</a:t>
+            </a:r>
+          </a:p>
+          <a:p>
             <a:pPr>
               <a:lnSpc>
                 <a:spcPct val="115000"/>
@@ -8989,15 +9328,6 @@
                 <a:spcPts val="1000"/>
               </a:spcAft>
             </a:pPr>
-            <a:r>
-              <a:rPr sz="1900" b="0" i="0">
-                <a:solidFill>
-                  <a:srgbClr val="1F2937"/>
-                </a:solidFill>
-                <a:latin typeface="Calibri"/>
-              </a:rPr>
-              <a:t>•  You cannot prompt your way to information the model does not have — you must supply it</a:t>
-            </a:r>
           </a:p>
           <a:p>
             <a:pPr>
@@ -9009,99 +9339,13 @@
               </a:spcAft>
             </a:pPr>
             <a:r>
-              <a:rPr sz="1900" b="0" i="0">
+              <a:rPr sz="1900" b="1" i="0">
                 <a:solidFill>
                   <a:srgbClr val="1F2937"/>
                 </a:solidFill>
                 <a:latin typeface="Calibri"/>
               </a:rPr>
-              <a:t>•  Grounding puts your passages in the context. That is all RAG means.</a:t>
-            </a:r>
-          </a:p>
-          <a:p>
-            <a:pPr>
-              <a:lnSpc>
-                <a:spcPct val="115000"/>
-              </a:lnSpc>
-              <a:spcAft>
-                <a:spcPts val="1000"/>
-              </a:spcAft>
-            </a:pPr>
-            <a:r>
-              <a:rPr sz="1900" b="1" i="0">
-                <a:solidFill>
-                  <a:srgbClr val="1F2937"/>
-                </a:solidFill>
-                <a:latin typeface="Calibri"/>
-              </a:rPr>
-              <a:t>•  It changes where the answer comes from. It does not install a truth check.</a:t>
-            </a:r>
-          </a:p>
-          <a:p>
-            <a:pPr>
-              <a:lnSpc>
-                <a:spcPct val="115000"/>
-              </a:lnSpc>
-              <a:spcAft>
-                <a:spcPts val="1000"/>
-              </a:spcAft>
-            </a:pPr>
-            <a:r>
-              <a:rPr sz="1900" b="0" i="0">
-                <a:solidFill>
-                  <a:srgbClr val="1F2937"/>
-                </a:solidFill>
-                <a:latin typeface="Calibri"/>
-              </a:rPr>
-              <a:t>•  Ask for quotations — then actually check them</a:t>
-            </a:r>
-          </a:p>
-          <a:p>
-            <a:pPr>
-              <a:lnSpc>
-                <a:spcPct val="115000"/>
-              </a:lnSpc>
-              <a:spcAft>
-                <a:spcPts val="1000"/>
-              </a:spcAft>
-            </a:pPr>
-            <a:r>
-              <a:rPr sz="1900" b="0" i="0">
-                <a:solidFill>
-                  <a:srgbClr val="1F2937"/>
-                </a:solidFill>
-                <a:latin typeface="Calibri"/>
-              </a:rPr>
-              <a:t>•  Three failures: answered from memory · wrong passage · over-read</a:t>
-            </a:r>
-          </a:p>
-          <a:p>
-            <a:pPr>
-              <a:lnSpc>
-                <a:spcPct val="115000"/>
-              </a:lnSpc>
-              <a:spcAft>
-                <a:spcPts val="1000"/>
-              </a:spcAft>
-            </a:pPr>
-          </a:p>
-          <a:p>
-            <a:pPr>
-              <a:lnSpc>
-                <a:spcPct val="115000"/>
-              </a:lnSpc>
-              <a:spcAft>
-                <a:spcPts val="1000"/>
-              </a:spcAft>
-            </a:pPr>
-            <a:r>
-              <a:rPr sz="1900" b="1" i="0">
-                <a:solidFill>
-                  <a:srgbClr val="1F2937"/>
-                </a:solidFill>
-                <a:latin typeface="Calibri"/>
-              </a:rPr>
-              <a:t>•  Next week:</a:t>
+              <a:t>•  The last one is structural and worth remembering:</a:t>
             </a:r>
           </a:p>
           <a:p>
@@ -9120,7 +9364,7 @@
                 </a:solidFill>
                 <a:latin typeface="Calibri"/>
               </a:rPr>
-              <a:t>—  Verification — you will build ten questions designed to break the thing you made today</a:t>
+              <a:t>—  Retrieval pulls passages, not whole documents. Anything requiring you to combine three separate places is fragile.</a:t>
             </a:r>
           </a:p>
         </p:txBody>
@@ -9214,20 +9458,54 @@
       <p:grpSpPr/>
       <p:sp>
         <p:nvSpPr>
-          <p:cNvPr id="2" name="Rectangle 1"/>
+          <p:cNvPr id="2" name="TextBox 1"/>
+          <p:cNvSpPr txBox="1"/>
+          <p:nvPr/>
+        </p:nvSpPr>
+        <p:spPr>
+          <a:xfrm>
+            <a:off x="777240" y="566928"/>
+            <a:ext cx="10637215" cy="822960"/>
+          </a:xfrm>
+          <a:prstGeom prst="rect">
+            <a:avLst/>
+          </a:prstGeom>
+          <a:noFill/>
+        </p:spPr>
+        <p:txBody>
+          <a:bodyPr wrap="square" lIns="0" rIns="0" tIns="0" bIns="0">
+            <a:spAutoFit/>
+          </a:bodyPr>
+          <a:lstStyle/>
+          <a:p>
+            <a:r>
+              <a:rPr sz="3000" b="1" i="0">
+                <a:solidFill>
+                  <a:srgbClr val="1F2937"/>
+                </a:solidFill>
+                <a:latin typeface="Calibri Light"/>
+              </a:rPr>
+              <a:t>Concepts You Must Be Able to Define and Diagnose</a:t>
+            </a:r>
+          </a:p>
+        </p:txBody>
+      </p:sp>
+      <p:sp>
+        <p:nvSpPr>
+          <p:cNvPr id="3" name="Rectangle 2"/>
           <p:cNvSpPr/>
           <p:nvPr/>
         </p:nvSpPr>
         <p:spPr>
           <a:xfrm>
-            <a:off x="0" y="0"/>
-            <a:ext cx="12191695" cy="6858000"/>
+            <a:off x="777240" y="1417320"/>
+            <a:ext cx="1051560" cy="38100"/>
           </a:xfrm>
           <a:prstGeom prst="rect">
             <a:avLst/>
           </a:prstGeom>
           <a:solidFill>
-            <a:srgbClr val="1F2937"/>
+            <a:srgbClr val="0F766E"/>
           </a:solidFill>
           <a:ln>
             <a:noFill/>
@@ -9258,54 +9536,20 @@
       </p:sp>
       <p:sp>
         <p:nvSpPr>
-          <p:cNvPr id="3" name="TextBox 2"/>
-          <p:cNvSpPr txBox="1"/>
-          <p:nvPr/>
-        </p:nvSpPr>
-        <p:spPr>
-          <a:xfrm>
-            <a:off x="777240" y="2468880"/>
-            <a:ext cx="10241280" cy="914400"/>
-          </a:xfrm>
-          <a:prstGeom prst="rect">
-            <a:avLst/>
-          </a:prstGeom>
-          <a:noFill/>
-        </p:spPr>
-        <p:txBody>
-          <a:bodyPr wrap="square" lIns="0" rIns="0" tIns="0" bIns="0">
-            <a:spAutoFit/>
-          </a:bodyPr>
-          <a:lstStyle/>
-          <a:p>
-            <a:r>
-              <a:rPr sz="4400" b="1" i="0">
-                <a:solidFill>
-                  <a:srgbClr val="FFFFFF"/>
-                </a:solidFill>
-                <a:latin typeface="Calibri Light"/>
-              </a:rPr>
-              <a:t>Questions?</a:t>
-            </a:r>
-          </a:p>
-        </p:txBody>
-      </p:sp>
-      <p:sp>
-        <p:nvSpPr>
           <p:cNvPr id="4" name="Rectangle 3"/>
           <p:cNvSpPr/>
           <p:nvPr/>
         </p:nvSpPr>
         <p:spPr>
           <a:xfrm>
-            <a:off x="777240" y="3566160"/>
-            <a:ext cx="1051560" cy="50800"/>
+            <a:off x="777240" y="1783080"/>
+            <a:ext cx="10637215" cy="4251960"/>
           </a:xfrm>
           <a:prstGeom prst="rect">
             <a:avLst/>
           </a:prstGeom>
           <a:solidFill>
-            <a:srgbClr val="0F766E"/>
+            <a:srgbClr val="F1F5F9"/>
           </a:solidFill>
           <a:ln>
             <a:noFill/>
@@ -9342,8 +9586,8 @@
         </p:nvSpPr>
         <p:spPr>
           <a:xfrm>
-            <a:off x="777240" y="3931920"/>
-            <a:ext cx="10241280" cy="914400"/>
+            <a:off x="1188720" y="2103120"/>
+            <a:ext cx="9814255" cy="3611880"/>
           </a:xfrm>
           <a:prstGeom prst="rect">
             <a:avLst/>
@@ -9357,34 +9601,261 @@
           <a:lstStyle/>
           <a:p>
             <a:pPr>
+              <a:lnSpc>
+                <a:spcPct val="115000"/>
+              </a:lnSpc>
+              <a:spcAft>
+                <a:spcPts val="1000"/>
+              </a:spcAft>
+            </a:pPr>
+            <a:r>
+              <a:rPr sz="1900" b="1" i="0">
+                <a:solidFill>
+                  <a:srgbClr val="1F2937"/>
+                </a:solidFill>
+                <a:latin typeface="Calibri"/>
+              </a:rPr>
+              <a:t>•  Grounding</a:t>
+            </a:r>
+          </a:p>
+          <a:p>
+            <a:pPr lvl="1">
+              <a:lnSpc>
+                <a:spcPct val="115000"/>
+              </a:lnSpc>
               <a:spcAft>
                 <a:spcPts val="500"/>
               </a:spcAft>
             </a:pPr>
             <a:r>
-              <a:rPr sz="1700" b="0" i="0">
-                <a:solidFill>
-                  <a:srgbClr val="FFFFFF"/>
-                </a:solidFill>
-                <a:latin typeface="Calibri"/>
-              </a:rPr>
-              <a:t>Mehmet Ali Akyol, PhD</a:t>
+              <a:rPr sz="1600" b="0" i="0">
+                <a:solidFill>
+                  <a:srgbClr val="333D4B"/>
+                </a:solidFill>
+                <a:latin typeface="Calibri"/>
+              </a:rPr>
+              <a:t>—  Placing relevant passages from chosen sources into the context so the model answers from them rather than from memory. Also called retrieval-augmented generation.</a:t>
             </a:r>
           </a:p>
           <a:p>
             <a:pPr>
+              <a:lnSpc>
+                <a:spcPct val="115000"/>
+              </a:lnSpc>
+              <a:spcAft>
+                <a:spcPts val="1000"/>
+              </a:spcAft>
+            </a:pPr>
+            <a:r>
+              <a:rPr sz="1900" b="1" i="0">
+                <a:solidFill>
+                  <a:srgbClr val="1F2937"/>
+                </a:solidFill>
+                <a:latin typeface="Calibri"/>
+              </a:rPr>
+              <a:t>•  What grounding does and does not do</a:t>
+            </a:r>
+          </a:p>
+          <a:p>
+            <a:pPr lvl="1">
+              <a:lnSpc>
+                <a:spcPct val="115000"/>
+              </a:lnSpc>
               <a:spcAft>
                 <a:spcPts val="500"/>
               </a:spcAft>
             </a:pPr>
             <a:r>
-              <a:rPr sz="1700" b="0" i="0">
-                <a:solidFill>
-                  <a:srgbClr val="C3D0DB"/>
-                </a:solidFill>
-                <a:latin typeface="Calibri"/>
-              </a:rPr>
-              <a:t>mehmetali.akyol@gmail.com</a:t>
+              <a:rPr sz="1600" b="0" i="0">
+                <a:solidFill>
+                  <a:srgbClr val="333D4B"/>
+                </a:solidFill>
+                <a:latin typeface="Calibri"/>
+              </a:rPr>
+              <a:t>—  Changes where the answer comes from. Does not install a truth check, and does not fix a wrong source.</a:t>
+            </a:r>
+          </a:p>
+          <a:p>
+            <a:pPr>
+              <a:lnSpc>
+                <a:spcPct val="115000"/>
+              </a:lnSpc>
+              <a:spcAft>
+                <a:spcPts val="1000"/>
+              </a:spcAft>
+            </a:pPr>
+            <a:r>
+              <a:rPr sz="1900" b="1" i="0">
+                <a:solidFill>
+                  <a:srgbClr val="1F2937"/>
+                </a:solidFill>
+                <a:latin typeface="Calibri"/>
+              </a:rPr>
+              <a:t>•  Why prompting cannot substitute</a:t>
+            </a:r>
+          </a:p>
+          <a:p>
+            <a:pPr lvl="1">
+              <a:lnSpc>
+                <a:spcPct val="115000"/>
+              </a:lnSpc>
+              <a:spcAft>
+                <a:spcPts val="500"/>
+              </a:spcAft>
+            </a:pPr>
+            <a:r>
+              <a:rPr sz="1600" b="0" i="0">
+                <a:solidFill>
+                  <a:srgbClr val="333D4B"/>
+                </a:solidFill>
+                <a:latin typeface="Calibri"/>
+              </a:rPr>
+              <a:t>—  Instructions change tone and shape, never available information. "Be accurate" adds authority, not facts.</a:t>
+            </a:r>
+          </a:p>
+          <a:p>
+            <a:pPr>
+              <a:lnSpc>
+                <a:spcPct val="115000"/>
+              </a:lnSpc>
+              <a:spcAft>
+                <a:spcPts val="1000"/>
+              </a:spcAft>
+            </a:pPr>
+            <a:r>
+              <a:rPr sz="1900" b="1" i="0">
+                <a:solidFill>
+                  <a:srgbClr val="1F2937"/>
+                </a:solidFill>
+                <a:latin typeface="Calibri"/>
+              </a:rPr>
+              <a:t>•  The three verification instructions</a:t>
+            </a:r>
+          </a:p>
+          <a:p>
+            <a:pPr lvl="1">
+              <a:lnSpc>
+                <a:spcPct val="115000"/>
+              </a:lnSpc>
+              <a:spcAft>
+                <a:spcPts val="500"/>
+              </a:spcAft>
+            </a:pPr>
+            <a:r>
+              <a:rPr sz="1600" b="0" i="0">
+                <a:solidFill>
+                  <a:srgbClr val="333D4B"/>
+                </a:solidFill>
+                <a:latin typeface="Calibri"/>
+              </a:rPr>
+              <a:t>—  Answer only from sources · quote the supporting sentence · a fixed, visible refusal string.</a:t>
+            </a:r>
+          </a:p>
+          <a:p>
+            <a:pPr>
+              <a:lnSpc>
+                <a:spcPct val="115000"/>
+              </a:lnSpc>
+              <a:spcAft>
+                <a:spcPts val="1000"/>
+              </a:spcAft>
+            </a:pPr>
+            <a:r>
+              <a:rPr sz="1900" b="1" i="0">
+                <a:solidFill>
+                  <a:srgbClr val="1F2937"/>
+                </a:solidFill>
+                <a:latin typeface="Calibri"/>
+              </a:rPr>
+              <a:t>•  Three grounded failure modes</a:t>
+            </a:r>
+          </a:p>
+          <a:p>
+            <a:pPr lvl="1">
+              <a:lnSpc>
+                <a:spcPct val="115000"/>
+              </a:lnSpc>
+              <a:spcAft>
+                <a:spcPts val="500"/>
+              </a:spcAft>
+            </a:pPr>
+            <a:r>
+              <a:rPr sz="1600" b="0" i="0">
+                <a:solidFill>
+                  <a:srgbClr val="333D4B"/>
+                </a:solidFill>
+                <a:latin typeface="Calibri"/>
+              </a:rPr>
+              <a:t>—  Answered from memory · retrieved the wrong passage · over-read the passage.</a:t>
+            </a:r>
+          </a:p>
+        </p:txBody>
+      </p:sp>
+      <p:sp>
+        <p:nvSpPr>
+          <p:cNvPr id="6" name="TextBox 5"/>
+          <p:cNvSpPr txBox="1"/>
+          <p:nvPr/>
+        </p:nvSpPr>
+        <p:spPr>
+          <a:xfrm>
+            <a:off x="777240" y="6355080"/>
+            <a:ext cx="10637215" cy="274320"/>
+          </a:xfrm>
+          <a:prstGeom prst="rect">
+            <a:avLst/>
+          </a:prstGeom>
+          <a:noFill/>
+        </p:spPr>
+        <p:txBody>
+          <a:bodyPr wrap="square" lIns="0" rIns="0" tIns="0" bIns="0">
+            <a:spAutoFit/>
+          </a:bodyPr>
+          <a:lstStyle/>
+          <a:p>
+            <a:r>
+              <a:rPr sz="1000" b="0" i="0">
+                <a:solidFill>
+                  <a:srgbClr val="6B7787"/>
+                </a:solidFill>
+                <a:latin typeface="Calibri"/>
+              </a:rPr>
+              <a:t>Week 7  ·  Prompt Engineering and Large Language Models</a:t>
+            </a:r>
+          </a:p>
+        </p:txBody>
+      </p:sp>
+      <p:sp>
+        <p:nvSpPr>
+          <p:cNvPr id="7" name="TextBox 6"/>
+          <p:cNvSpPr txBox="1"/>
+          <p:nvPr/>
+        </p:nvSpPr>
+        <p:spPr>
+          <a:xfrm>
+            <a:off x="10500055" y="6355080"/>
+            <a:ext cx="914400" cy="274320"/>
+          </a:xfrm>
+          <a:prstGeom prst="rect">
+            <a:avLst/>
+          </a:prstGeom>
+          <a:noFill/>
+        </p:spPr>
+        <p:txBody>
+          <a:bodyPr wrap="square" lIns="0" rIns="0" tIns="0" bIns="0">
+            <a:spAutoFit/>
+          </a:bodyPr>
+          <a:lstStyle/>
+          <a:p>
+            <a:pPr algn="r"/>
+            <a:r>
+              <a:rPr sz="1000" b="0" i="0">
+                <a:solidFill>
+                  <a:srgbClr val="6B7787"/>
+                </a:solidFill>
+                <a:latin typeface="Calibri"/>
+              </a:rPr>
+              <a:t>19</a:t>
             </a:r>
           </a:p>
         </p:txBody>
@@ -9687,6 +10158,532 @@
                 <a:latin typeface="Calibri"/>
               </a:rPr>
               <a:t>2</a:t>
+            </a:r>
+          </a:p>
+        </p:txBody>
+      </p:sp>
+    </p:spTree>
+  </p:cSld>
+  <p:clrMapOvr>
+    <a:masterClrMapping/>
+  </p:clrMapOvr>
+</p:sld>
+</file>
+
+<file path=ppt/slides/slide20.xml><?xml version="1.0" encoding="utf-8"?>
+<p:sld xmlns:a="http://schemas.openxmlformats.org/drawingml/2006/main" xmlns:p="http://schemas.openxmlformats.org/presentationml/2006/main" xmlns:r="http://schemas.openxmlformats.org/officeDocument/2006/relationships">
+  <p:cSld>
+    <p:spTree>
+      <p:nvGrpSpPr>
+        <p:cNvPr id="1" name=""/>
+        <p:cNvGrpSpPr/>
+        <p:nvPr/>
+      </p:nvGrpSpPr>
+      <p:grpSpPr/>
+      <p:sp>
+        <p:nvSpPr>
+          <p:cNvPr id="2" name="TextBox 1"/>
+          <p:cNvSpPr txBox="1"/>
+          <p:nvPr/>
+        </p:nvSpPr>
+        <p:spPr>
+          <a:xfrm>
+            <a:off x="777240" y="566928"/>
+            <a:ext cx="10637215" cy="822960"/>
+          </a:xfrm>
+          <a:prstGeom prst="rect">
+            <a:avLst/>
+          </a:prstGeom>
+          <a:noFill/>
+        </p:spPr>
+        <p:txBody>
+          <a:bodyPr wrap="square" lIns="0" rIns="0" tIns="0" bIns="0">
+            <a:spAutoFit/>
+          </a:bodyPr>
+          <a:lstStyle/>
+          <a:p>
+            <a:r>
+              <a:rPr sz="3000" b="1" i="0">
+                <a:solidFill>
+                  <a:srgbClr val="1F2937"/>
+                </a:solidFill>
+                <a:latin typeface="Calibri Light"/>
+              </a:rPr>
+              <a:t>Wrap-Up</a:t>
+            </a:r>
+          </a:p>
+        </p:txBody>
+      </p:sp>
+      <p:sp>
+        <p:nvSpPr>
+          <p:cNvPr id="3" name="Rectangle 2"/>
+          <p:cNvSpPr/>
+          <p:nvPr/>
+        </p:nvSpPr>
+        <p:spPr>
+          <a:xfrm>
+            <a:off x="777240" y="1417320"/>
+            <a:ext cx="1051560" cy="38100"/>
+          </a:xfrm>
+          <a:prstGeom prst="rect">
+            <a:avLst/>
+          </a:prstGeom>
+          <a:solidFill>
+            <a:srgbClr val="0F766E"/>
+          </a:solidFill>
+          <a:ln>
+            <a:noFill/>
+          </a:ln>
+          <a:effectLst/>
+        </p:spPr>
+        <p:style>
+          <a:lnRef idx="1">
+            <a:schemeClr val="accent1"/>
+          </a:lnRef>
+          <a:fillRef idx="3">
+            <a:schemeClr val="accent1"/>
+          </a:fillRef>
+          <a:effectRef idx="2">
+            <a:schemeClr val="accent1"/>
+          </a:effectRef>
+          <a:fontRef idx="minor">
+            <a:schemeClr val="lt1"/>
+          </a:fontRef>
+        </p:style>
+        <p:txBody>
+          <a:bodyPr rtlCol="0" anchor="ctr"/>
+          <a:lstStyle/>
+          <a:p>
+            <a:pPr algn="ctr"/>
+          </a:p>
+        </p:txBody>
+      </p:sp>
+      <p:sp>
+        <p:nvSpPr>
+          <p:cNvPr id="4" name="TextBox 3"/>
+          <p:cNvSpPr txBox="1"/>
+          <p:nvPr/>
+        </p:nvSpPr>
+        <p:spPr>
+          <a:xfrm>
+            <a:off x="777240" y="1783080"/>
+            <a:ext cx="10637215" cy="4343400"/>
+          </a:xfrm>
+          <a:prstGeom prst="rect">
+            <a:avLst/>
+          </a:prstGeom>
+          <a:noFill/>
+        </p:spPr>
+        <p:txBody>
+          <a:bodyPr wrap="square" lIns="0" rIns="0" tIns="0" bIns="0">
+            <a:spAutoFit/>
+          </a:bodyPr>
+          <a:lstStyle/>
+          <a:p>
+            <a:pPr>
+              <a:lnSpc>
+                <a:spcPct val="115000"/>
+              </a:lnSpc>
+              <a:spcAft>
+                <a:spcPts val="1000"/>
+              </a:spcAft>
+            </a:pPr>
+            <a:r>
+              <a:rPr sz="1900" b="0" i="0">
+                <a:solidFill>
+                  <a:srgbClr val="1F2937"/>
+                </a:solidFill>
+                <a:latin typeface="Calibri"/>
+              </a:rPr>
+              <a:t>•  You cannot prompt your way to information the model does not have — you must supply it</a:t>
+            </a:r>
+          </a:p>
+          <a:p>
+            <a:pPr>
+              <a:lnSpc>
+                <a:spcPct val="115000"/>
+              </a:lnSpc>
+              <a:spcAft>
+                <a:spcPts val="1000"/>
+              </a:spcAft>
+            </a:pPr>
+            <a:r>
+              <a:rPr sz="1900" b="0" i="0">
+                <a:solidFill>
+                  <a:srgbClr val="1F2937"/>
+                </a:solidFill>
+                <a:latin typeface="Calibri"/>
+              </a:rPr>
+              <a:t>•  Grounding puts your passages in the context. That is all RAG means.</a:t>
+            </a:r>
+          </a:p>
+          <a:p>
+            <a:pPr>
+              <a:lnSpc>
+                <a:spcPct val="115000"/>
+              </a:lnSpc>
+              <a:spcAft>
+                <a:spcPts val="1000"/>
+              </a:spcAft>
+            </a:pPr>
+            <a:r>
+              <a:rPr sz="1900" b="1" i="0">
+                <a:solidFill>
+                  <a:srgbClr val="1F2937"/>
+                </a:solidFill>
+                <a:latin typeface="Calibri"/>
+              </a:rPr>
+              <a:t>•  It changes where the answer comes from. It does not install a truth check.</a:t>
+            </a:r>
+          </a:p>
+          <a:p>
+            <a:pPr>
+              <a:lnSpc>
+                <a:spcPct val="115000"/>
+              </a:lnSpc>
+              <a:spcAft>
+                <a:spcPts val="1000"/>
+              </a:spcAft>
+            </a:pPr>
+            <a:r>
+              <a:rPr sz="1900" b="0" i="0">
+                <a:solidFill>
+                  <a:srgbClr val="1F2937"/>
+                </a:solidFill>
+                <a:latin typeface="Calibri"/>
+              </a:rPr>
+              <a:t>•  Ask for quotations — then actually check them</a:t>
+            </a:r>
+          </a:p>
+          <a:p>
+            <a:pPr>
+              <a:lnSpc>
+                <a:spcPct val="115000"/>
+              </a:lnSpc>
+              <a:spcAft>
+                <a:spcPts val="1000"/>
+              </a:spcAft>
+            </a:pPr>
+            <a:r>
+              <a:rPr sz="1900" b="0" i="0">
+                <a:solidFill>
+                  <a:srgbClr val="1F2937"/>
+                </a:solidFill>
+                <a:latin typeface="Calibri"/>
+              </a:rPr>
+              <a:t>•  Three failures: answered from memory · wrong passage · over-read</a:t>
+            </a:r>
+          </a:p>
+          <a:p>
+            <a:pPr>
+              <a:lnSpc>
+                <a:spcPct val="115000"/>
+              </a:lnSpc>
+              <a:spcAft>
+                <a:spcPts val="1000"/>
+              </a:spcAft>
+            </a:pPr>
+          </a:p>
+          <a:p>
+            <a:pPr>
+              <a:lnSpc>
+                <a:spcPct val="115000"/>
+              </a:lnSpc>
+              <a:spcAft>
+                <a:spcPts val="1000"/>
+              </a:spcAft>
+            </a:pPr>
+            <a:r>
+              <a:rPr sz="1900" b="1" i="0">
+                <a:solidFill>
+                  <a:srgbClr val="1F2937"/>
+                </a:solidFill>
+                <a:latin typeface="Calibri"/>
+              </a:rPr>
+              <a:t>•  Next week:</a:t>
+            </a:r>
+          </a:p>
+          <a:p>
+            <a:pPr lvl="1">
+              <a:lnSpc>
+                <a:spcPct val="115000"/>
+              </a:lnSpc>
+              <a:spcAft>
+                <a:spcPts val="500"/>
+              </a:spcAft>
+            </a:pPr>
+            <a:r>
+              <a:rPr sz="1600" b="0" i="0">
+                <a:solidFill>
+                  <a:srgbClr val="333D4B"/>
+                </a:solidFill>
+                <a:latin typeface="Calibri"/>
+              </a:rPr>
+              <a:t>—  Verification — you will build ten questions designed to break the thing you made today</a:t>
+            </a:r>
+          </a:p>
+        </p:txBody>
+      </p:sp>
+      <p:sp>
+        <p:nvSpPr>
+          <p:cNvPr id="5" name="TextBox 4"/>
+          <p:cNvSpPr txBox="1"/>
+          <p:nvPr/>
+        </p:nvSpPr>
+        <p:spPr>
+          <a:xfrm>
+            <a:off x="777240" y="6355080"/>
+            <a:ext cx="10637215" cy="274320"/>
+          </a:xfrm>
+          <a:prstGeom prst="rect">
+            <a:avLst/>
+          </a:prstGeom>
+          <a:noFill/>
+        </p:spPr>
+        <p:txBody>
+          <a:bodyPr wrap="square" lIns="0" rIns="0" tIns="0" bIns="0">
+            <a:spAutoFit/>
+          </a:bodyPr>
+          <a:lstStyle/>
+          <a:p>
+            <a:r>
+              <a:rPr sz="1000" b="0" i="0">
+                <a:solidFill>
+                  <a:srgbClr val="6B7787"/>
+                </a:solidFill>
+                <a:latin typeface="Calibri"/>
+              </a:rPr>
+              <a:t>Week 7  ·  Prompt Engineering and Large Language Models</a:t>
+            </a:r>
+          </a:p>
+        </p:txBody>
+      </p:sp>
+      <p:sp>
+        <p:nvSpPr>
+          <p:cNvPr id="6" name="TextBox 5"/>
+          <p:cNvSpPr txBox="1"/>
+          <p:nvPr/>
+        </p:nvSpPr>
+        <p:spPr>
+          <a:xfrm>
+            <a:off x="10500055" y="6355080"/>
+            <a:ext cx="914400" cy="274320"/>
+          </a:xfrm>
+          <a:prstGeom prst="rect">
+            <a:avLst/>
+          </a:prstGeom>
+          <a:noFill/>
+        </p:spPr>
+        <p:txBody>
+          <a:bodyPr wrap="square" lIns="0" rIns="0" tIns="0" bIns="0">
+            <a:spAutoFit/>
+          </a:bodyPr>
+          <a:lstStyle/>
+          <a:p>
+            <a:pPr algn="r"/>
+            <a:r>
+              <a:rPr sz="1000" b="0" i="0">
+                <a:solidFill>
+                  <a:srgbClr val="6B7787"/>
+                </a:solidFill>
+                <a:latin typeface="Calibri"/>
+              </a:rPr>
+              <a:t>20</a:t>
+            </a:r>
+          </a:p>
+        </p:txBody>
+      </p:sp>
+    </p:spTree>
+  </p:cSld>
+  <p:clrMapOvr>
+    <a:masterClrMapping/>
+  </p:clrMapOvr>
+</p:sld>
+</file>
+
+<file path=ppt/slides/slide21.xml><?xml version="1.0" encoding="utf-8"?>
+<p:sld xmlns:a="http://schemas.openxmlformats.org/drawingml/2006/main" xmlns:p="http://schemas.openxmlformats.org/presentationml/2006/main" xmlns:r="http://schemas.openxmlformats.org/officeDocument/2006/relationships">
+  <p:cSld>
+    <p:spTree>
+      <p:nvGrpSpPr>
+        <p:cNvPr id="1" name=""/>
+        <p:cNvGrpSpPr/>
+        <p:nvPr/>
+      </p:nvGrpSpPr>
+      <p:grpSpPr/>
+      <p:sp>
+        <p:nvSpPr>
+          <p:cNvPr id="2" name="Rectangle 1"/>
+          <p:cNvSpPr/>
+          <p:nvPr/>
+        </p:nvSpPr>
+        <p:spPr>
+          <a:xfrm>
+            <a:off x="0" y="0"/>
+            <a:ext cx="12191695" cy="6858000"/>
+          </a:xfrm>
+          <a:prstGeom prst="rect">
+            <a:avLst/>
+          </a:prstGeom>
+          <a:solidFill>
+            <a:srgbClr val="1F2937"/>
+          </a:solidFill>
+          <a:ln>
+            <a:noFill/>
+          </a:ln>
+          <a:effectLst/>
+        </p:spPr>
+        <p:style>
+          <a:lnRef idx="1">
+            <a:schemeClr val="accent1"/>
+          </a:lnRef>
+          <a:fillRef idx="3">
+            <a:schemeClr val="accent1"/>
+          </a:fillRef>
+          <a:effectRef idx="2">
+            <a:schemeClr val="accent1"/>
+          </a:effectRef>
+          <a:fontRef idx="minor">
+            <a:schemeClr val="lt1"/>
+          </a:fontRef>
+        </p:style>
+        <p:txBody>
+          <a:bodyPr rtlCol="0" anchor="ctr"/>
+          <a:lstStyle/>
+          <a:p>
+            <a:pPr algn="ctr"/>
+          </a:p>
+        </p:txBody>
+      </p:sp>
+      <p:sp>
+        <p:nvSpPr>
+          <p:cNvPr id="3" name="TextBox 2"/>
+          <p:cNvSpPr txBox="1"/>
+          <p:nvPr/>
+        </p:nvSpPr>
+        <p:spPr>
+          <a:xfrm>
+            <a:off x="777240" y="2468880"/>
+            <a:ext cx="10241280" cy="914400"/>
+          </a:xfrm>
+          <a:prstGeom prst="rect">
+            <a:avLst/>
+          </a:prstGeom>
+          <a:noFill/>
+        </p:spPr>
+        <p:txBody>
+          <a:bodyPr wrap="square" lIns="0" rIns="0" tIns="0" bIns="0">
+            <a:spAutoFit/>
+          </a:bodyPr>
+          <a:lstStyle/>
+          <a:p>
+            <a:r>
+              <a:rPr sz="4400" b="1" i="0">
+                <a:solidFill>
+                  <a:srgbClr val="FFFFFF"/>
+                </a:solidFill>
+                <a:latin typeface="Calibri Light"/>
+              </a:rPr>
+              <a:t>Questions?</a:t>
+            </a:r>
+          </a:p>
+        </p:txBody>
+      </p:sp>
+      <p:sp>
+        <p:nvSpPr>
+          <p:cNvPr id="4" name="Rectangle 3"/>
+          <p:cNvSpPr/>
+          <p:nvPr/>
+        </p:nvSpPr>
+        <p:spPr>
+          <a:xfrm>
+            <a:off x="777240" y="3566160"/>
+            <a:ext cx="1051560" cy="50800"/>
+          </a:xfrm>
+          <a:prstGeom prst="rect">
+            <a:avLst/>
+          </a:prstGeom>
+          <a:solidFill>
+            <a:srgbClr val="0F766E"/>
+          </a:solidFill>
+          <a:ln>
+            <a:noFill/>
+          </a:ln>
+          <a:effectLst/>
+        </p:spPr>
+        <p:style>
+          <a:lnRef idx="1">
+            <a:schemeClr val="accent1"/>
+          </a:lnRef>
+          <a:fillRef idx="3">
+            <a:schemeClr val="accent1"/>
+          </a:fillRef>
+          <a:effectRef idx="2">
+            <a:schemeClr val="accent1"/>
+          </a:effectRef>
+          <a:fontRef idx="minor">
+            <a:schemeClr val="lt1"/>
+          </a:fontRef>
+        </p:style>
+        <p:txBody>
+          <a:bodyPr rtlCol="0" anchor="ctr"/>
+          <a:lstStyle/>
+          <a:p>
+            <a:pPr algn="ctr"/>
+          </a:p>
+        </p:txBody>
+      </p:sp>
+      <p:sp>
+        <p:nvSpPr>
+          <p:cNvPr id="5" name="TextBox 4"/>
+          <p:cNvSpPr txBox="1"/>
+          <p:nvPr/>
+        </p:nvSpPr>
+        <p:spPr>
+          <a:xfrm>
+            <a:off x="777240" y="3931920"/>
+            <a:ext cx="10241280" cy="914400"/>
+          </a:xfrm>
+          <a:prstGeom prst="rect">
+            <a:avLst/>
+          </a:prstGeom>
+          <a:noFill/>
+        </p:spPr>
+        <p:txBody>
+          <a:bodyPr wrap="square" lIns="0" rIns="0" tIns="0" bIns="0">
+            <a:spAutoFit/>
+          </a:bodyPr>
+          <a:lstStyle/>
+          <a:p>
+            <a:pPr>
+              <a:spcAft>
+                <a:spcPts val="500"/>
+              </a:spcAft>
+            </a:pPr>
+            <a:r>
+              <a:rPr sz="1700" b="0" i="0">
+                <a:solidFill>
+                  <a:srgbClr val="FFFFFF"/>
+                </a:solidFill>
+                <a:latin typeface="Calibri"/>
+              </a:rPr>
+              <a:t>Mehmet Ali Akyol, PhD</a:t>
+            </a:r>
+          </a:p>
+          <a:p>
+            <a:pPr>
+              <a:spcAft>
+                <a:spcPts val="500"/>
+              </a:spcAft>
+            </a:pPr>
+            <a:r>
+              <a:rPr sz="1700" b="0" i="0">
+                <a:solidFill>
+                  <a:srgbClr val="C3D0DB"/>
+                </a:solidFill>
+                <a:latin typeface="Calibri"/>
+              </a:rPr>
+              <a:t>mehmetali.akyol@gmail.com</a:t>
             </a:r>
           </a:p>
         </p:txBody>

</xml_diff>